<commit_message>
enlace a diapos sesión 2
</commit_message>
<xml_diff>
--- a/docs/tema1/diapositivas/control_versiones_documentacion.pptx
+++ b/docs/tema1/diapositivas/control_versiones_documentacion.pptx
@@ -5,7 +5,7 @@
     <p:sldMasterId id="2147483648" r:id="rId1"/>
   </p:sldMasterIdLst>
   <p:notesMasterIdLst>
-    <p:notesMasterId r:id="rId17"/>
+    <p:notesMasterId r:id="rId18"/>
   </p:notesMasterIdLst>
   <p:sldIdLst>
     <p:sldId id="256" r:id="rId2"/>
@@ -21,8 +21,9 @@
     <p:sldId id="278" r:id="rId12"/>
     <p:sldId id="279" r:id="rId13"/>
     <p:sldId id="280" r:id="rId14"/>
-    <p:sldId id="268" r:id="rId15"/>
-    <p:sldId id="269" r:id="rId16"/>
+    <p:sldId id="281" r:id="rId15"/>
+    <p:sldId id="268" r:id="rId16"/>
+    <p:sldId id="269" r:id="rId17"/>
   </p:sldIdLst>
   <p:sldSz cx="12192000" cy="6858000"/>
   <p:notesSz cx="6858000" cy="12192000"/>
@@ -1512,6 +1513,200 @@
   <p:cSld>
     <p:spTree>
       <p:nvGrpSpPr>
+        <p:cNvPr id="1" name="">
+          <a:extLst>
+            <a:ext uri="{FF2B5EF4-FFF2-40B4-BE49-F238E27FC236}">
+              <a16:creationId xmlns:a16="http://schemas.microsoft.com/office/drawing/2014/main" id="{9D2E0A7A-9974-D4B9-7FAC-76B99195F776}"/>
+            </a:ext>
+          </a:extLst>
+        </p:cNvPr>
+        <p:cNvGrpSpPr/>
+        <p:nvPr/>
+      </p:nvGrpSpPr>
+      <p:grpSpPr>
+        <a:xfrm>
+          <a:off x="0" y="0"/>
+          <a:ext cx="0" cy="0"/>
+          <a:chOff x="0" y="0"/>
+          <a:chExt cx="0" cy="0"/>
+        </a:xfrm>
+      </p:grpSpPr>
+      <p:sp>
+        <p:nvSpPr>
+          <p:cNvPr id="191" name="PlaceHolder 1">
+            <a:extLst>
+              <a:ext uri="{FF2B5EF4-FFF2-40B4-BE49-F238E27FC236}">
+                <a16:creationId xmlns:a16="http://schemas.microsoft.com/office/drawing/2014/main" id="{4FA8AE20-E5C5-F132-0BD2-BCC3B7230DC6}"/>
+              </a:ext>
+            </a:extLst>
+          </p:cNvPr>
+          <p:cNvSpPr>
+            <a:spLocks noGrp="1" noRot="1" noChangeAspect="1"/>
+          </p:cNvSpPr>
+          <p:nvPr>
+            <p:ph type="sldImg"/>
+          </p:nvPr>
+        </p:nvSpPr>
+        <p:spPr>
+          <a:xfrm>
+            <a:off x="685800" y="1143000"/>
+            <a:ext cx="5486400" cy="3086100"/>
+          </a:xfrm>
+          <a:prstGeom prst="rect">
+            <a:avLst/>
+          </a:prstGeom>
+          <a:ln w="0">
+            <a:noFill/>
+          </a:ln>
+        </p:spPr>
+      </p:sp>
+      <p:sp>
+        <p:nvSpPr>
+          <p:cNvPr id="192" name="PlaceHolder 2">
+            <a:extLst>
+              <a:ext uri="{FF2B5EF4-FFF2-40B4-BE49-F238E27FC236}">
+                <a16:creationId xmlns:a16="http://schemas.microsoft.com/office/drawing/2014/main" id="{8A004843-D16C-A767-2CAB-2585AFA6B0FA}"/>
+              </a:ext>
+            </a:extLst>
+          </p:cNvPr>
+          <p:cNvSpPr>
+            <a:spLocks noGrp="1"/>
+          </p:cNvSpPr>
+          <p:nvPr>
+            <p:ph type="body"/>
+          </p:nvPr>
+        </p:nvSpPr>
+        <p:spPr>
+          <a:xfrm>
+            <a:off x="685800" y="4400640"/>
+            <a:ext cx="5486040" cy="3600000"/>
+          </a:xfrm>
+          <a:prstGeom prst="rect">
+            <a:avLst/>
+          </a:prstGeom>
+          <a:noFill/>
+          <a:ln w="0">
+            <a:noFill/>
+          </a:ln>
+        </p:spPr>
+        <p:txBody>
+          <a:bodyPr lIns="91440" tIns="45720" rIns="91440" bIns="45720" anchor="t">
+            <a:noAutofit/>
+          </a:bodyPr>
+          <a:lstStyle/>
+          <a:p>
+            <a:pPr indent="0">
+              <a:buNone/>
+            </a:pPr>
+            <a:endParaRPr lang="en-US" sz="1800" b="0" u="none" strike="noStrike">
+              <a:solidFill>
+                <a:srgbClr val="000000"/>
+              </a:solidFill>
+              <a:effectLst/>
+              <a:uFillTx/>
+              <a:latin typeface="Arial"/>
+            </a:endParaRPr>
+          </a:p>
+        </p:txBody>
+      </p:sp>
+      <p:sp>
+        <p:nvSpPr>
+          <p:cNvPr id="193" name="PlaceHolder 3">
+            <a:extLst>
+              <a:ext uri="{FF2B5EF4-FFF2-40B4-BE49-F238E27FC236}">
+                <a16:creationId xmlns:a16="http://schemas.microsoft.com/office/drawing/2014/main" id="{7A6FD358-E531-CFB5-9725-576014724569}"/>
+              </a:ext>
+            </a:extLst>
+          </p:cNvPr>
+          <p:cNvSpPr>
+            <a:spLocks noGrp="1"/>
+          </p:cNvSpPr>
+          <p:nvPr>
+            <p:ph type="sldNum" idx="5"/>
+          </p:nvPr>
+        </p:nvSpPr>
+        <p:spPr>
+          <a:xfrm>
+            <a:off x="3884760" y="8685360"/>
+            <a:ext cx="2971440" cy="458280"/>
+          </a:xfrm>
+          <a:prstGeom prst="rect">
+            <a:avLst/>
+          </a:prstGeom>
+          <a:noFill/>
+          <a:ln w="0">
+            <a:noFill/>
+          </a:ln>
+        </p:spPr>
+        <p:txBody>
+          <a:bodyPr lIns="91440" tIns="45720" rIns="91440" bIns="45720" anchor="b">
+            <a:noAutofit/>
+          </a:bodyPr>
+          <a:lstStyle>
+            <a:lvl1pPr indent="0" algn="r" defTabSz="914400">
+              <a:lnSpc>
+                <a:spcPct val="100000"/>
+              </a:lnSpc>
+              <a:buNone/>
+              <a:defRPr lang="en-US" sz="1200" b="0" u="none" strike="noStrike">
+                <a:solidFill>
+                  <a:schemeClr val="dk1"/>
+                </a:solidFill>
+                <a:effectLst/>
+                <a:uFillTx/>
+                <a:latin typeface="+mn-lt"/>
+                <a:ea typeface="+mn-ea"/>
+              </a:defRPr>
+            </a:lvl1pPr>
+          </a:lstStyle>
+          <a:p>
+            <a:pPr indent="0" algn="r" defTabSz="914400">
+              <a:lnSpc>
+                <a:spcPct val="100000"/>
+              </a:lnSpc>
+              <a:buNone/>
+            </a:pPr>
+            <a:fld id="{22358A90-62AA-4E7E-871C-5E646CD8E978}" type="slidenum">
+              <a:rPr lang="en-US" sz="1200" b="0" u="none" strike="noStrike">
+                <a:solidFill>
+                  <a:schemeClr val="dk1"/>
+                </a:solidFill>
+                <a:effectLst/>
+                <a:uFillTx/>
+                <a:latin typeface="+mn-lt"/>
+                <a:ea typeface="+mn-ea"/>
+              </a:rPr>
+              <a:t>14</a:t>
+            </a:fld>
+            <a:endParaRPr lang="en-US" sz="1200" b="0" u="none" strike="noStrike">
+              <a:solidFill>
+                <a:srgbClr val="000000"/>
+              </a:solidFill>
+              <a:effectLst/>
+              <a:uFillTx/>
+              <a:latin typeface="Times New Roman"/>
+            </a:endParaRPr>
+          </a:p>
+        </p:txBody>
+      </p:sp>
+    </p:spTree>
+    <p:extLst>
+      <p:ext uri="{BB962C8B-B14F-4D97-AF65-F5344CB8AC3E}">
+        <p14:creationId xmlns:p14="http://schemas.microsoft.com/office/powerpoint/2010/main" val="81458388"/>
+      </p:ext>
+    </p:extLst>
+  </p:cSld>
+  <p:clrMapOvr>
+    <a:masterClrMapping/>
+  </p:clrMapOvr>
+</p:notes>
+</file>
+
+<file path=ppt/notesSlides/notesSlide15.xml><?xml version="1.0" encoding="utf-8"?>
+<p:notes xmlns:a="http://schemas.openxmlformats.org/drawingml/2006/main" xmlns:r="http://schemas.openxmlformats.org/officeDocument/2006/relationships" xmlns:p="http://schemas.openxmlformats.org/presentationml/2006/main">
+  <p:cSld>
+    <p:spTree>
+      <p:nvGrpSpPr>
         <p:cNvPr id="1" name=""/>
         <p:cNvGrpSpPr/>
         <p:nvPr/>
@@ -1651,7 +1846,7 @@
                 <a:latin typeface="+mn-lt"/>
                 <a:ea typeface="+mn-ea"/>
               </a:rPr>
-              <a:t>14</a:t>
+              <a:t>15</a:t>
             </a:fld>
             <a:endParaRPr lang="en-US" sz="1200" b="0" u="none" strike="noStrike">
               <a:solidFill>
@@ -1672,7 +1867,7 @@
 </p:notes>
 </file>
 
-<file path=ppt/notesSlides/notesSlide15.xml><?xml version="1.0" encoding="utf-8"?>
+<file path=ppt/notesSlides/notesSlide16.xml><?xml version="1.0" encoding="utf-8"?>
 <p:notes xmlns:a="http://schemas.openxmlformats.org/drawingml/2006/main" xmlns:r="http://schemas.openxmlformats.org/officeDocument/2006/relationships" xmlns:p="http://schemas.openxmlformats.org/presentationml/2006/main">
   <p:cSld>
     <p:spTree>
@@ -1816,7 +2011,7 @@
                 <a:latin typeface="+mn-lt"/>
                 <a:ea typeface="+mn-ea"/>
               </a:rPr>
-              <a:t>15</a:t>
+              <a:t>16</a:t>
             </a:fld>
             <a:endParaRPr lang="en-US" sz="1200" b="0" u="none" strike="noStrike">
               <a:solidFill>
@@ -9737,8 +9932,8 @@
         </p:blipFill>
         <p:spPr>
           <a:xfrm>
-            <a:off x="548640" y="1548000"/>
-            <a:ext cx="6034680" cy="3396240"/>
+            <a:off x="683678" y="1330650"/>
+            <a:ext cx="6553909" cy="3915540"/>
           </a:xfrm>
           <a:prstGeom prst="rect">
             <a:avLst/>
@@ -9763,8 +9958,8 @@
         </p:nvSpPr>
         <p:spPr>
           <a:xfrm>
-            <a:off x="6858000" y="1463040"/>
-            <a:ext cx="4480200" cy="2377080"/>
+            <a:off x="7393881" y="1463040"/>
+            <a:ext cx="4114441" cy="2377080"/>
           </a:xfrm>
           <a:prstGeom prst="roundRect">
             <a:avLst>
@@ -10424,7 +10619,7 @@
         </p:nvSpPr>
         <p:spPr>
           <a:xfrm>
-            <a:off x="7040880" y="4160520"/>
+            <a:off x="7393882" y="4160520"/>
             <a:ext cx="4114440" cy="868320"/>
           </a:xfrm>
           <a:prstGeom prst="roundRect">
@@ -11597,7 +11792,7 @@
         <p:spPr>
           <a:xfrm>
             <a:off x="5413320" y="1076850"/>
-            <a:ext cx="3200040" cy="369574"/>
+            <a:ext cx="3200040" cy="431130"/>
           </a:xfrm>
           <a:prstGeom prst="rect">
             <a:avLst/>
@@ -11631,7 +11826,7 @@
               </a:lnSpc>
             </a:pPr>
             <a:r>
-              <a:rPr lang="en-US" sz="1400" b="1" u="none" strike="noStrike" dirty="0" err="1">
+              <a:rPr lang="en-US" b="1" u="none" strike="noStrike" dirty="0" err="1">
                 <a:solidFill>
                   <a:srgbClr val="0A5C48"/>
                 </a:solidFill>
@@ -11641,7 +11836,7 @@
               <a:t>Versionado</a:t>
             </a:r>
             <a:r>
-              <a:rPr lang="en-US" sz="1400" b="1" u="none" strike="noStrike" dirty="0">
+              <a:rPr lang="en-US" b="1" u="none" strike="noStrike" dirty="0">
                 <a:solidFill>
                   <a:srgbClr val="0A5C48"/>
                 </a:solidFill>
@@ -11651,7 +11846,7 @@
               <a:t> </a:t>
             </a:r>
             <a:r>
-              <a:rPr lang="en-US" sz="1400" b="1" u="none" strike="noStrike" dirty="0" err="1">
+              <a:rPr lang="en-US" b="1" u="none" strike="noStrike" dirty="0" err="1">
                 <a:solidFill>
                   <a:srgbClr val="0A5C48"/>
                 </a:solidFill>
@@ -11660,7 +11855,7 @@
               </a:rPr>
               <a:t>semántico</a:t>
             </a:r>
-            <a:endParaRPr lang="en-US" sz="1400" b="0" u="none" strike="noStrike" dirty="0">
+            <a:endParaRPr lang="en-US" b="0" u="none" strike="noStrike" dirty="0">
               <a:solidFill>
                 <a:srgbClr val="000000"/>
               </a:solidFill>
@@ -11684,7 +11879,7 @@
         </p:nvSpPr>
         <p:spPr>
           <a:xfrm>
-            <a:off x="5367600" y="1488330"/>
+            <a:off x="5367600" y="1669089"/>
             <a:ext cx="1188360" cy="347040"/>
           </a:xfrm>
           <a:prstGeom prst="rect">
@@ -11754,7 +11949,7 @@
         </p:nvSpPr>
         <p:spPr>
           <a:xfrm>
-            <a:off x="5367600" y="1458884"/>
+            <a:off x="5367600" y="1639643"/>
             <a:ext cx="1188360" cy="369574"/>
           </a:xfrm>
           <a:prstGeom prst="rect">
@@ -11822,7 +12017,7 @@
         </p:nvSpPr>
         <p:spPr>
           <a:xfrm>
-            <a:off x="6556320" y="1488330"/>
+            <a:off x="6556320" y="1669089"/>
             <a:ext cx="2742840" cy="347040"/>
           </a:xfrm>
           <a:prstGeom prst="rect">
@@ -11892,7 +12087,7 @@
         </p:nvSpPr>
         <p:spPr>
           <a:xfrm>
-            <a:off x="6556320" y="1458884"/>
+            <a:off x="6556320" y="1639643"/>
             <a:ext cx="2742840" cy="369574"/>
           </a:xfrm>
           <a:prstGeom prst="rect">
@@ -11960,7 +12155,7 @@
         </p:nvSpPr>
         <p:spPr>
           <a:xfrm>
-            <a:off x="5367600" y="1835730"/>
+            <a:off x="5367600" y="2016489"/>
             <a:ext cx="1188360" cy="347040"/>
           </a:xfrm>
           <a:prstGeom prst="rect">
@@ -12030,7 +12225,7 @@
         </p:nvSpPr>
         <p:spPr>
           <a:xfrm>
-            <a:off x="5385960" y="1797103"/>
+            <a:off x="5385960" y="1977862"/>
             <a:ext cx="1151640" cy="369574"/>
           </a:xfrm>
           <a:prstGeom prst="rect">
@@ -12098,7 +12293,7 @@
         </p:nvSpPr>
         <p:spPr>
           <a:xfrm>
-            <a:off x="6556320" y="1835730"/>
+            <a:off x="6556320" y="2016489"/>
             <a:ext cx="2742840" cy="347040"/>
           </a:xfrm>
           <a:prstGeom prst="rect">
@@ -12168,7 +12363,7 @@
         </p:nvSpPr>
         <p:spPr>
           <a:xfrm>
-            <a:off x="6574680" y="1797103"/>
+            <a:off x="6574680" y="1977862"/>
             <a:ext cx="2706120" cy="369574"/>
           </a:xfrm>
           <a:prstGeom prst="rect">
@@ -12236,7 +12431,7 @@
         </p:nvSpPr>
         <p:spPr>
           <a:xfrm>
-            <a:off x="5367600" y="2183130"/>
+            <a:off x="5367600" y="2363889"/>
             <a:ext cx="1188360" cy="347040"/>
           </a:xfrm>
           <a:prstGeom prst="rect">
@@ -12306,7 +12501,7 @@
         </p:nvSpPr>
         <p:spPr>
           <a:xfrm>
-            <a:off x="5385960" y="2144503"/>
+            <a:off x="5385960" y="2325262"/>
             <a:ext cx="1151640" cy="369574"/>
           </a:xfrm>
           <a:prstGeom prst="rect">
@@ -12374,7 +12569,7 @@
         </p:nvSpPr>
         <p:spPr>
           <a:xfrm>
-            <a:off x="6556320" y="2183130"/>
+            <a:off x="6556320" y="2363889"/>
             <a:ext cx="2742840" cy="347040"/>
           </a:xfrm>
           <a:prstGeom prst="rect">
@@ -12444,7 +12639,7 @@
         </p:nvSpPr>
         <p:spPr>
           <a:xfrm>
-            <a:off x="6574680" y="2144503"/>
+            <a:off x="6574680" y="2325262"/>
             <a:ext cx="2706120" cy="369574"/>
           </a:xfrm>
           <a:prstGeom prst="rect">
@@ -12512,7 +12707,7 @@
         </p:nvSpPr>
         <p:spPr>
           <a:xfrm>
-            <a:off x="5367600" y="2530890"/>
+            <a:off x="5367600" y="2711649"/>
             <a:ext cx="1188360" cy="347040"/>
           </a:xfrm>
           <a:prstGeom prst="rect">
@@ -12582,7 +12777,7 @@
         </p:nvSpPr>
         <p:spPr>
           <a:xfrm>
-            <a:off x="5385960" y="2491903"/>
+            <a:off x="5385960" y="2672662"/>
             <a:ext cx="1151640" cy="369574"/>
           </a:xfrm>
           <a:prstGeom prst="rect">
@@ -12650,7 +12845,7 @@
         </p:nvSpPr>
         <p:spPr>
           <a:xfrm>
-            <a:off x="6556320" y="2530890"/>
+            <a:off x="6556320" y="2711649"/>
             <a:ext cx="2742840" cy="347040"/>
           </a:xfrm>
           <a:prstGeom prst="rect">
@@ -12720,7 +12915,7 @@
         </p:nvSpPr>
         <p:spPr>
           <a:xfrm>
-            <a:off x="6574680" y="2491903"/>
+            <a:off x="6574680" y="2672662"/>
             <a:ext cx="2706120" cy="369574"/>
           </a:xfrm>
           <a:prstGeom prst="rect">
@@ -12789,7 +12984,7 @@
         <p:spPr>
           <a:xfrm>
             <a:off x="1664280" y="3591450"/>
-            <a:ext cx="3382920" cy="1096920"/>
+            <a:ext cx="3382920" cy="1342056"/>
           </a:xfrm>
           <a:prstGeom prst="roundRect">
             <a:avLst>
@@ -12826,7 +13021,7 @@
           <a:fontRef idx="minor"/>
         </p:style>
         <p:txBody>
-          <a:bodyPr lIns="90000" tIns="45000" rIns="90000" bIns="45000" anchor="ctr">
+          <a:bodyPr lIns="90000" tIns="45000" rIns="90000" bIns="45000" anchor="t">
             <a:noAutofit/>
           </a:bodyPr>
           <a:lstStyle/>
@@ -12835,9 +13030,12 @@
               <a:lnSpc>
                 <a:spcPct val="100000"/>
               </a:lnSpc>
+              <a:spcAft>
+                <a:spcPts val="600"/>
+              </a:spcAft>
             </a:pPr>
             <a:r>
-              <a:rPr lang="en-US" sz="1400" b="1" u="none" strike="noStrike">
+              <a:rPr lang="en-US" sz="1400" b="1" u="none" strike="noStrike" dirty="0" err="1">
                 <a:solidFill>
                   <a:srgbClr val="0A5C48"/>
                 </a:solidFill>
@@ -12846,7 +13044,7 @@
               </a:rPr>
               <a:t>Ejemplos</a:t>
             </a:r>
-            <a:endParaRPr lang="en-US" sz="1400" b="0" u="none" strike="noStrike">
+            <a:endParaRPr lang="en-US" sz="1400" b="0" u="none" strike="noStrike" dirty="0">
               <a:solidFill>
                 <a:srgbClr val="000000"/>
               </a:solidFill>
@@ -12859,18 +13057,31 @@
               <a:lnSpc>
                 <a:spcPct val="100000"/>
               </a:lnSpc>
+              <a:spcAft>
+                <a:spcPts val="600"/>
+              </a:spcAft>
             </a:pPr>
             <a:r>
-              <a:rPr lang="en-US" sz="1400" b="0" u="none" strike="noStrike">
-                <a:solidFill>
-                  <a:srgbClr val="2D3436"/>
-                </a:solidFill>
-                <a:effectLst/>
-                <a:uFillTx/>
-              </a:rPr>
-              <a:t>`1.4.2 → 1.4.3`  corrección</a:t>
-            </a:r>
-            <a:endParaRPr lang="en-US" sz="1400" b="0" u="none" strike="noStrike">
+              <a:rPr lang="en-US" sz="1400" b="0" u="none" strike="noStrike" dirty="0">
+                <a:solidFill>
+                  <a:srgbClr val="2D3436"/>
+                </a:solidFill>
+                <a:effectLst/>
+                <a:uFillTx/>
+              </a:rPr>
+              <a:t>`1.4.2 → 1.4.3`  </a:t>
+            </a:r>
+            <a:r>
+              <a:rPr lang="en-US" sz="1400" b="0" u="none" strike="noStrike" dirty="0" err="1">
+                <a:solidFill>
+                  <a:srgbClr val="2D3436"/>
+                </a:solidFill>
+                <a:effectLst/>
+                <a:uFillTx/>
+              </a:rPr>
+              <a:t>corrección</a:t>
+            </a:r>
+            <a:endParaRPr lang="en-US" sz="1400" b="0" u="none" strike="noStrike" dirty="0">
               <a:solidFill>
                 <a:srgbClr val="000000"/>
               </a:solidFill>
@@ -12883,18 +13094,51 @@
               <a:lnSpc>
                 <a:spcPct val="100000"/>
               </a:lnSpc>
+              <a:spcAft>
+                <a:spcPts val="600"/>
+              </a:spcAft>
             </a:pPr>
             <a:r>
-              <a:rPr lang="en-US" sz="1400" b="0" u="none" strike="noStrike">
-                <a:solidFill>
-                  <a:srgbClr val="2D3436"/>
-                </a:solidFill>
-                <a:effectLst/>
-                <a:uFillTx/>
-              </a:rPr>
-              <a:t>`1.4.2 → 1.5.0`  nueva funcionalidad</a:t>
-            </a:r>
-            <a:endParaRPr lang="en-US" sz="1400" b="0" u="none" strike="noStrike">
+              <a:rPr lang="en-US" sz="1400" b="0" u="none" strike="noStrike" dirty="0">
+                <a:solidFill>
+                  <a:srgbClr val="2D3436"/>
+                </a:solidFill>
+                <a:effectLst/>
+                <a:uFillTx/>
+              </a:rPr>
+              <a:t>`1.4.2 → 1.5.0`  </a:t>
+            </a:r>
+            <a:r>
+              <a:rPr lang="en-US" sz="1400" b="0" u="none" strike="noStrike" dirty="0" err="1">
+                <a:solidFill>
+                  <a:srgbClr val="2D3436"/>
+                </a:solidFill>
+                <a:effectLst/>
+                <a:uFillTx/>
+              </a:rPr>
+              <a:t>nueva</a:t>
+            </a:r>
+            <a:r>
+              <a:rPr lang="en-US" sz="1400" b="0" u="none" strike="noStrike" dirty="0">
+                <a:solidFill>
+                  <a:srgbClr val="2D3436"/>
+                </a:solidFill>
+                <a:effectLst/>
+                <a:uFillTx/>
+              </a:rPr>
+              <a:t> </a:t>
+            </a:r>
+            <a:r>
+              <a:rPr lang="en-US" sz="1400" b="0" u="none" strike="noStrike" dirty="0" err="1">
+                <a:solidFill>
+                  <a:srgbClr val="2D3436"/>
+                </a:solidFill>
+                <a:effectLst/>
+                <a:uFillTx/>
+              </a:rPr>
+              <a:t>funcionalidad</a:t>
+            </a:r>
+            <a:endParaRPr lang="en-US" sz="1400" b="0" u="none" strike="noStrike" dirty="0">
               <a:solidFill>
                 <a:srgbClr val="000000"/>
               </a:solidFill>
@@ -12907,18 +13151,41 @@
               <a:lnSpc>
                 <a:spcPct val="100000"/>
               </a:lnSpc>
+              <a:spcAft>
+                <a:spcPts val="600"/>
+              </a:spcAft>
             </a:pPr>
             <a:r>
-              <a:rPr lang="en-US" sz="1400" b="0" u="none" strike="noStrike">
-                <a:solidFill>
-                  <a:srgbClr val="2D3436"/>
-                </a:solidFill>
-                <a:effectLst/>
-                <a:uFillTx/>
-              </a:rPr>
-              <a:t>`1.4.2 → 2.0.0`  cambio incompatible</a:t>
-            </a:r>
-            <a:endParaRPr lang="en-US" sz="1400" b="0" u="none" strike="noStrike">
+              <a:rPr lang="en-US" sz="1400" b="0" u="none" strike="noStrike" dirty="0">
+                <a:solidFill>
+                  <a:srgbClr val="2D3436"/>
+                </a:solidFill>
+                <a:effectLst/>
+                <a:uFillTx/>
+              </a:rPr>
+              <a:t>`1.4.2 → 2.0.0`  </a:t>
+            </a:r>
+            <a:r>
+              <a:rPr lang="en-US" sz="1400" b="0" u="none" strike="noStrike" dirty="0" err="1">
+                <a:solidFill>
+                  <a:srgbClr val="2D3436"/>
+                </a:solidFill>
+                <a:effectLst/>
+                <a:uFillTx/>
+              </a:rPr>
+              <a:t>cambio</a:t>
+            </a:r>
+            <a:r>
+              <a:rPr lang="en-US" sz="1400" b="0" u="none" strike="noStrike" dirty="0">
+                <a:solidFill>
+                  <a:srgbClr val="2D3436"/>
+                </a:solidFill>
+                <a:effectLst/>
+                <a:uFillTx/>
+              </a:rPr>
+              <a:t> incompatible</a:t>
+            </a:r>
+            <a:endParaRPr lang="en-US" sz="1400" b="0" u="none" strike="noStrike" dirty="0">
               <a:solidFill>
                 <a:srgbClr val="000000"/>
               </a:solidFill>
@@ -12942,8 +13209,8 @@
         </p:nvSpPr>
         <p:spPr>
           <a:xfrm>
-            <a:off x="5413320" y="3591450"/>
-            <a:ext cx="5668920" cy="1096920"/>
+            <a:off x="5413320" y="3591449"/>
+            <a:ext cx="5668920" cy="1342057"/>
           </a:xfrm>
           <a:prstGeom prst="roundRect">
             <a:avLst>
@@ -12980,7 +13247,7 @@
           <a:fontRef idx="minor"/>
         </p:style>
         <p:txBody>
-          <a:bodyPr lIns="90000" tIns="45000" rIns="90000" bIns="45000" anchor="ctr">
+          <a:bodyPr lIns="90000" tIns="45000" rIns="90000" bIns="45000" anchor="t">
             <a:noAutofit/>
           </a:bodyPr>
           <a:lstStyle/>
@@ -12989,18 +13256,31 @@
               <a:lnSpc>
                 <a:spcPct val="100000"/>
               </a:lnSpc>
+              <a:spcAft>
+                <a:spcPts val="600"/>
+              </a:spcAft>
             </a:pPr>
             <a:r>
-              <a:rPr lang="en-US" sz="1400" b="1" u="none" strike="noStrike">
+              <a:rPr lang="en-US" sz="1400" b="1" u="none" strike="noStrike" dirty="0">
                 <a:solidFill>
                   <a:srgbClr val="0A5C48"/>
                 </a:solidFill>
                 <a:effectLst/>
                 <a:uFillTx/>
               </a:rPr>
-              <a:t>En el módulo</a:t>
-            </a:r>
-            <a:endParaRPr lang="en-US" sz="1400" b="0" u="none" strike="noStrike">
+              <a:t>En el </a:t>
+            </a:r>
+            <a:r>
+              <a:rPr lang="en-US" sz="1400" b="1" u="none" strike="noStrike" dirty="0" err="1">
+                <a:solidFill>
+                  <a:srgbClr val="0A5C48"/>
+                </a:solidFill>
+                <a:effectLst/>
+                <a:uFillTx/>
+              </a:rPr>
+              <a:t>módulo</a:t>
+            </a:r>
+            <a:endParaRPr lang="en-US" sz="1400" b="0" u="none" strike="noStrike" dirty="0">
               <a:solidFill>
                 <a:srgbClr val="000000"/>
               </a:solidFill>
@@ -13013,18 +13293,261 @@
               <a:lnSpc>
                 <a:spcPct val="100000"/>
               </a:lnSpc>
+              <a:spcAft>
+                <a:spcPts val="600"/>
+              </a:spcAft>
             </a:pPr>
             <a:r>
-              <a:rPr lang="en-US" sz="1400" b="0" u="none" strike="noStrike">
-                <a:solidFill>
-                  <a:srgbClr val="2D3436"/>
-                </a:solidFill>
-                <a:effectLst/>
-                <a:uFillTx/>
-              </a:rPr>
-              <a:t>La etiqueta `v0.1.0` identificará un primer estado útil del repositorio del curso. No tiene por qué coincidir con la versión interna de la aplicación.</a:t>
-            </a:r>
-            <a:endParaRPr lang="en-US" sz="1400" b="0" u="none" strike="noStrike">
+              <a:rPr lang="en-US" sz="1400" b="0" u="none" strike="noStrike" dirty="0">
+                <a:solidFill>
+                  <a:srgbClr val="2D3436"/>
+                </a:solidFill>
+                <a:effectLst/>
+                <a:uFillTx/>
+              </a:rPr>
+              <a:t>La </a:t>
+            </a:r>
+            <a:r>
+              <a:rPr lang="en-US" sz="1400" b="0" u="none" strike="noStrike" dirty="0" err="1">
+                <a:solidFill>
+                  <a:srgbClr val="2D3436"/>
+                </a:solidFill>
+                <a:effectLst/>
+                <a:uFillTx/>
+              </a:rPr>
+              <a:t>etiqueta</a:t>
+            </a:r>
+            <a:r>
+              <a:rPr lang="en-US" sz="1400" b="0" u="none" strike="noStrike" dirty="0">
+                <a:solidFill>
+                  <a:srgbClr val="2D3436"/>
+                </a:solidFill>
+                <a:effectLst/>
+                <a:uFillTx/>
+              </a:rPr>
+              <a:t> `v0.1.0` </a:t>
+            </a:r>
+            <a:r>
+              <a:rPr lang="en-US" sz="1400" b="0" u="none" strike="noStrike" dirty="0" err="1">
+                <a:solidFill>
+                  <a:srgbClr val="2D3436"/>
+                </a:solidFill>
+                <a:effectLst/>
+                <a:uFillTx/>
+              </a:rPr>
+              <a:t>identificará</a:t>
+            </a:r>
+            <a:r>
+              <a:rPr lang="en-US" sz="1400" b="0" u="none" strike="noStrike" dirty="0">
+                <a:solidFill>
+                  <a:srgbClr val="2D3436"/>
+                </a:solidFill>
+                <a:effectLst/>
+                <a:uFillTx/>
+              </a:rPr>
+              <a:t> un primer </a:t>
+            </a:r>
+            <a:r>
+              <a:rPr lang="en-US" sz="1400" b="0" u="none" strike="noStrike" dirty="0" err="1">
+                <a:solidFill>
+                  <a:srgbClr val="2D3436"/>
+                </a:solidFill>
+                <a:effectLst/>
+                <a:uFillTx/>
+              </a:rPr>
+              <a:t>estado</a:t>
+            </a:r>
+            <a:r>
+              <a:rPr lang="en-US" sz="1400" b="0" u="none" strike="noStrike" dirty="0">
+                <a:solidFill>
+                  <a:srgbClr val="2D3436"/>
+                </a:solidFill>
+                <a:effectLst/>
+                <a:uFillTx/>
+              </a:rPr>
+              <a:t> </a:t>
+            </a:r>
+            <a:r>
+              <a:rPr lang="en-US" sz="1400" b="0" u="none" strike="noStrike" dirty="0" err="1">
+                <a:solidFill>
+                  <a:srgbClr val="2D3436"/>
+                </a:solidFill>
+                <a:effectLst/>
+                <a:uFillTx/>
+              </a:rPr>
+              <a:t>útil</a:t>
+            </a:r>
+            <a:r>
+              <a:rPr lang="en-US" sz="1400" b="0" u="none" strike="noStrike" dirty="0">
+                <a:solidFill>
+                  <a:srgbClr val="2D3436"/>
+                </a:solidFill>
+                <a:effectLst/>
+                <a:uFillTx/>
+              </a:rPr>
+              <a:t> del </a:t>
+            </a:r>
+            <a:r>
+              <a:rPr lang="en-US" sz="1400" b="0" u="none" strike="noStrike" dirty="0" err="1">
+                <a:solidFill>
+                  <a:srgbClr val="2D3436"/>
+                </a:solidFill>
+                <a:effectLst/>
+                <a:uFillTx/>
+              </a:rPr>
+              <a:t>repositorio</a:t>
+            </a:r>
+            <a:r>
+              <a:rPr lang="en-US" sz="1400" b="0" u="none" strike="noStrike" dirty="0">
+                <a:solidFill>
+                  <a:srgbClr val="2D3436"/>
+                </a:solidFill>
+                <a:effectLst/>
+                <a:uFillTx/>
+              </a:rPr>
+              <a:t> del </a:t>
+            </a:r>
+            <a:r>
+              <a:rPr lang="en-US" sz="1400" b="0" u="none" strike="noStrike" dirty="0" err="1">
+                <a:solidFill>
+                  <a:srgbClr val="2D3436"/>
+                </a:solidFill>
+                <a:effectLst/>
+                <a:uFillTx/>
+              </a:rPr>
+              <a:t>curso</a:t>
+            </a:r>
+            <a:r>
+              <a:rPr lang="en-US" sz="1400" b="0" u="none" strike="noStrike" dirty="0">
+                <a:solidFill>
+                  <a:srgbClr val="2D3436"/>
+                </a:solidFill>
+                <a:effectLst/>
+                <a:uFillTx/>
+              </a:rPr>
+              <a:t>. No </a:t>
+            </a:r>
+            <a:r>
+              <a:rPr lang="en-US" sz="1400" b="0" u="none" strike="noStrike" dirty="0" err="1">
+                <a:solidFill>
+                  <a:srgbClr val="2D3436"/>
+                </a:solidFill>
+                <a:effectLst/>
+                <a:uFillTx/>
+              </a:rPr>
+              <a:t>tiene</a:t>
+            </a:r>
+            <a:r>
+              <a:rPr lang="en-US" sz="1400" b="0" u="none" strike="noStrike" dirty="0">
+                <a:solidFill>
+                  <a:srgbClr val="2D3436"/>
+                </a:solidFill>
+                <a:effectLst/>
+                <a:uFillTx/>
+              </a:rPr>
+              <a:t> </a:t>
+            </a:r>
+            <a:r>
+              <a:rPr lang="en-US" sz="1400" b="0" u="none" strike="noStrike" dirty="0" err="1">
+                <a:solidFill>
+                  <a:srgbClr val="2D3436"/>
+                </a:solidFill>
+                <a:effectLst/>
+                <a:uFillTx/>
+              </a:rPr>
+              <a:t>por</a:t>
+            </a:r>
+            <a:r>
+              <a:rPr lang="en-US" sz="1400" b="0" u="none" strike="noStrike" dirty="0">
+                <a:solidFill>
+                  <a:srgbClr val="2D3436"/>
+                </a:solidFill>
+                <a:effectLst/>
+                <a:uFillTx/>
+              </a:rPr>
+              <a:t> </a:t>
+            </a:r>
+            <a:r>
+              <a:rPr lang="en-US" sz="1400" b="0" u="none" strike="noStrike" dirty="0" err="1">
+                <a:solidFill>
+                  <a:srgbClr val="2D3436"/>
+                </a:solidFill>
+                <a:effectLst/>
+                <a:uFillTx/>
+              </a:rPr>
+              <a:t>qué</a:t>
+            </a:r>
+            <a:r>
+              <a:rPr lang="en-US" sz="1400" b="0" u="none" strike="noStrike" dirty="0">
+                <a:solidFill>
+                  <a:srgbClr val="2D3436"/>
+                </a:solidFill>
+                <a:effectLst/>
+                <a:uFillTx/>
+              </a:rPr>
+              <a:t> </a:t>
+            </a:r>
+            <a:r>
+              <a:rPr lang="en-US" sz="1400" b="0" u="none" strike="noStrike" dirty="0" err="1">
+                <a:solidFill>
+                  <a:srgbClr val="2D3436"/>
+                </a:solidFill>
+                <a:effectLst/>
+                <a:uFillTx/>
+              </a:rPr>
+              <a:t>coincidir</a:t>
+            </a:r>
+            <a:r>
+              <a:rPr lang="en-US" sz="1400" b="0" u="none" strike="noStrike" dirty="0">
+                <a:solidFill>
+                  <a:srgbClr val="2D3436"/>
+                </a:solidFill>
+                <a:effectLst/>
+                <a:uFillTx/>
+              </a:rPr>
+              <a:t> con la </a:t>
+            </a:r>
+            <a:r>
+              <a:rPr lang="en-US" sz="1400" b="0" u="none" strike="noStrike" dirty="0" err="1">
+                <a:solidFill>
+                  <a:srgbClr val="2D3436"/>
+                </a:solidFill>
+                <a:effectLst/>
+                <a:uFillTx/>
+              </a:rPr>
+              <a:t>versión</a:t>
+            </a:r>
+            <a:r>
+              <a:rPr lang="en-US" sz="1400" b="0" u="none" strike="noStrike" dirty="0">
+                <a:solidFill>
+                  <a:srgbClr val="2D3436"/>
+                </a:solidFill>
+                <a:effectLst/>
+                <a:uFillTx/>
+              </a:rPr>
+              <a:t> interna de la </a:t>
+            </a:r>
+            <a:r>
+              <a:rPr lang="en-US" sz="1400" b="0" u="none" strike="noStrike" dirty="0" err="1">
+                <a:solidFill>
+                  <a:srgbClr val="2D3436"/>
+                </a:solidFill>
+                <a:effectLst/>
+                <a:uFillTx/>
+              </a:rPr>
+              <a:t>aplicación</a:t>
+            </a:r>
+            <a:r>
+              <a:rPr lang="en-US" sz="1400" b="0" u="none" strike="noStrike" dirty="0">
+                <a:solidFill>
+                  <a:srgbClr val="2D3436"/>
+                </a:solidFill>
+                <a:effectLst/>
+                <a:uFillTx/>
+              </a:rPr>
+              <a:t>.</a:t>
+            </a:r>
+            <a:endParaRPr lang="en-US" sz="1400" b="0" u="none" strike="noStrike" dirty="0">
               <a:solidFill>
                 <a:srgbClr val="000000"/>
               </a:solidFill>
@@ -13048,6 +13571,1993 @@
 </file>
 
 <file path=ppt/slides/slide14.xml><?xml version="1.0" encoding="utf-8"?>
+<p:sld xmlns:a="http://schemas.openxmlformats.org/drawingml/2006/main" xmlns:r="http://schemas.openxmlformats.org/officeDocument/2006/relationships" xmlns:p="http://schemas.openxmlformats.org/presentationml/2006/main">
+  <p:cSld>
+    <p:spTree>
+      <p:nvGrpSpPr>
+        <p:cNvPr id="1" name="">
+          <a:extLst>
+            <a:ext uri="{FF2B5EF4-FFF2-40B4-BE49-F238E27FC236}">
+              <a16:creationId xmlns:a16="http://schemas.microsoft.com/office/drawing/2014/main" id="{53AF4DF8-747E-1194-8972-E2636E3F22E6}"/>
+            </a:ext>
+          </a:extLst>
+        </p:cNvPr>
+        <p:cNvGrpSpPr/>
+        <p:nvPr/>
+      </p:nvGrpSpPr>
+      <p:grpSpPr>
+        <a:xfrm>
+          <a:off x="0" y="0"/>
+          <a:ext cx="0" cy="0"/>
+          <a:chOff x="0" y="0"/>
+          <a:chExt cx="0" cy="0"/>
+        </a:xfrm>
+      </p:grpSpPr>
+      <p:sp>
+        <p:nvSpPr>
+          <p:cNvPr id="9" name="Shape 18">
+            <a:extLst>
+              <a:ext uri="{FF2B5EF4-FFF2-40B4-BE49-F238E27FC236}">
+                <a16:creationId xmlns:a16="http://schemas.microsoft.com/office/drawing/2014/main" id="{024F3726-E686-F1C0-2C0A-7FC48A58C6D0}"/>
+              </a:ext>
+            </a:extLst>
+          </p:cNvPr>
+          <p:cNvSpPr/>
+          <p:nvPr/>
+        </p:nvSpPr>
+        <p:spPr>
+          <a:xfrm>
+            <a:off x="937260" y="5463540"/>
+            <a:ext cx="10560960" cy="594000"/>
+          </a:xfrm>
+          <a:prstGeom prst="roundRect">
+            <a:avLst>
+              <a:gd name="adj" fmla="val 12308"/>
+            </a:avLst>
+          </a:prstGeom>
+          <a:solidFill>
+            <a:srgbClr val="FFFDE7"/>
+          </a:solidFill>
+          <a:ln w="16510">
+            <a:solidFill>
+              <a:srgbClr val="00ACC1"/>
+            </a:solidFill>
+            <a:round/>
+          </a:ln>
+        </p:spPr>
+        <p:style>
+          <a:lnRef idx="0">
+            <a:scrgbClr r="0" g="0" b="0"/>
+          </a:lnRef>
+          <a:fillRef idx="0">
+            <a:scrgbClr r="0" g="0" b="0"/>
+          </a:fillRef>
+          <a:effectRef idx="0">
+            <a:scrgbClr r="0" g="0" b="0"/>
+          </a:effectRef>
+          <a:fontRef idx="minor"/>
+        </p:style>
+        <p:txBody>
+          <a:bodyPr lIns="90000" tIns="45000" rIns="90000" bIns="45000" anchor="t">
+            <a:noAutofit/>
+          </a:bodyPr>
+          <a:lstStyle/>
+          <a:p>
+            <a:endParaRPr lang="en-US" sz="1800" b="0" u="none" strike="noStrike">
+              <a:solidFill>
+                <a:srgbClr val="000000"/>
+              </a:solidFill>
+              <a:effectLst/>
+              <a:uFillTx/>
+              <a:latin typeface="Arial"/>
+            </a:endParaRPr>
+          </a:p>
+        </p:txBody>
+      </p:sp>
+      <p:sp>
+        <p:nvSpPr>
+          <p:cNvPr id="14" name="Shape 0">
+            <a:extLst>
+              <a:ext uri="{FF2B5EF4-FFF2-40B4-BE49-F238E27FC236}">
+                <a16:creationId xmlns:a16="http://schemas.microsoft.com/office/drawing/2014/main" id="{7D18884D-FFA8-5666-4803-12C42D3C3C76}"/>
+              </a:ext>
+            </a:extLst>
+          </p:cNvPr>
+          <p:cNvSpPr/>
+          <p:nvPr/>
+        </p:nvSpPr>
+        <p:spPr>
+          <a:xfrm>
+            <a:off x="0" y="0"/>
+            <a:ext cx="12188520" cy="776880"/>
+          </a:xfrm>
+          <a:prstGeom prst="rect">
+            <a:avLst/>
+          </a:prstGeom>
+          <a:solidFill>
+            <a:srgbClr val="004D40"/>
+          </a:solidFill>
+          <a:ln w="12700">
+            <a:solidFill>
+              <a:srgbClr val="004D40"/>
+            </a:solidFill>
+            <a:round/>
+          </a:ln>
+        </p:spPr>
+        <p:style>
+          <a:lnRef idx="0">
+            <a:scrgbClr r="0" g="0" b="0"/>
+          </a:lnRef>
+          <a:fillRef idx="0">
+            <a:scrgbClr r="0" g="0" b="0"/>
+          </a:fillRef>
+          <a:effectRef idx="0">
+            <a:scrgbClr r="0" g="0" b="0"/>
+          </a:effectRef>
+          <a:fontRef idx="minor"/>
+        </p:style>
+        <p:txBody>
+          <a:bodyPr lIns="90000" tIns="45000" rIns="90000" bIns="45000" anchor="t">
+            <a:noAutofit/>
+          </a:bodyPr>
+          <a:lstStyle/>
+          <a:p>
+            <a:endParaRPr lang="en-US" sz="1800" b="0" u="none" strike="noStrike">
+              <a:solidFill>
+                <a:srgbClr val="FFFFFF"/>
+              </a:solidFill>
+              <a:effectLst/>
+              <a:uFillTx/>
+              <a:latin typeface="Arial"/>
+            </a:endParaRPr>
+          </a:p>
+        </p:txBody>
+      </p:sp>
+      <p:sp>
+        <p:nvSpPr>
+          <p:cNvPr id="15" name="Text 1">
+            <a:extLst>
+              <a:ext uri="{FF2B5EF4-FFF2-40B4-BE49-F238E27FC236}">
+                <a16:creationId xmlns:a16="http://schemas.microsoft.com/office/drawing/2014/main" id="{19C7C3E0-CBD5-4D75-811A-7C5EA8C0F012}"/>
+              </a:ext>
+            </a:extLst>
+          </p:cNvPr>
+          <p:cNvSpPr/>
+          <p:nvPr/>
+        </p:nvSpPr>
+        <p:spPr>
+          <a:xfrm>
+            <a:off x="384120" y="18360"/>
+            <a:ext cx="11420640" cy="712800"/>
+          </a:xfrm>
+          <a:prstGeom prst="rect">
+            <a:avLst/>
+          </a:prstGeom>
+          <a:noFill/>
+          <a:ln w="0">
+            <a:noFill/>
+          </a:ln>
+        </p:spPr>
+        <p:style>
+          <a:lnRef idx="0">
+            <a:scrgbClr r="0" g="0" b="0"/>
+          </a:lnRef>
+          <a:fillRef idx="0">
+            <a:scrgbClr r="0" g="0" b="0"/>
+          </a:fillRef>
+          <a:effectRef idx="0">
+            <a:scrgbClr r="0" g="0" b="0"/>
+          </a:effectRef>
+          <a:fontRef idx="minor"/>
+        </p:style>
+        <p:txBody>
+          <a:bodyPr lIns="90000" tIns="45000" rIns="90000" bIns="45000" anchor="ctr">
+            <a:normAutofit/>
+          </a:bodyPr>
+          <a:lstStyle/>
+          <a:p>
+            <a:pPr defTabSz="457200">
+              <a:lnSpc>
+                <a:spcPct val="100000"/>
+              </a:lnSpc>
+            </a:pPr>
+            <a:r>
+              <a:rPr lang="en-US" sz="2800" b="1" dirty="0">
+                <a:solidFill>
+                  <a:srgbClr val="FFFFFF"/>
+                </a:solidFill>
+                <a:latin typeface="Aptos Display"/>
+              </a:rPr>
+              <a:t>La </a:t>
+            </a:r>
+            <a:r>
+              <a:rPr lang="en-US" sz="2800" b="1" dirty="0" err="1">
+                <a:solidFill>
+                  <a:srgbClr val="FFFFFF"/>
+                </a:solidFill>
+                <a:latin typeface="Aptos Display"/>
+              </a:rPr>
+              <a:t>documentación</a:t>
+            </a:r>
+            <a:r>
+              <a:rPr lang="en-US" sz="2800" b="1" dirty="0">
+                <a:solidFill>
+                  <a:srgbClr val="FFFFFF"/>
+                </a:solidFill>
+                <a:latin typeface="Aptos Display"/>
+              </a:rPr>
+              <a:t> también se </a:t>
+            </a:r>
+            <a:r>
+              <a:rPr lang="en-US" sz="2800" b="1" dirty="0" err="1">
+                <a:solidFill>
+                  <a:srgbClr val="FFFFFF"/>
+                </a:solidFill>
+                <a:latin typeface="Aptos Display"/>
+              </a:rPr>
+              <a:t>versiona</a:t>
+            </a:r>
+            <a:endParaRPr lang="en-US" sz="2800" dirty="0">
+              <a:solidFill>
+                <a:srgbClr val="000000"/>
+              </a:solidFill>
+            </a:endParaRPr>
+          </a:p>
+        </p:txBody>
+      </p:sp>
+      <p:sp>
+        <p:nvSpPr>
+          <p:cNvPr id="16" name="Text 2">
+            <a:extLst>
+              <a:ext uri="{FF2B5EF4-FFF2-40B4-BE49-F238E27FC236}">
+                <a16:creationId xmlns:a16="http://schemas.microsoft.com/office/drawing/2014/main" id="{40010421-49D1-FDAF-9FA1-8A0E514BA4FB}"/>
+              </a:ext>
+            </a:extLst>
+          </p:cNvPr>
+          <p:cNvSpPr/>
+          <p:nvPr/>
+        </p:nvSpPr>
+        <p:spPr>
+          <a:xfrm>
+            <a:off x="548640" y="6492240"/>
+            <a:ext cx="11091240" cy="228240"/>
+          </a:xfrm>
+          <a:prstGeom prst="rect">
+            <a:avLst/>
+          </a:prstGeom>
+          <a:noFill/>
+          <a:ln w="0">
+            <a:noFill/>
+          </a:ln>
+        </p:spPr>
+        <p:style>
+          <a:lnRef idx="0">
+            <a:scrgbClr r="0" g="0" b="0"/>
+          </a:lnRef>
+          <a:fillRef idx="0">
+            <a:scrgbClr r="0" g="0" b="0"/>
+          </a:fillRef>
+          <a:effectRef idx="0">
+            <a:scrgbClr r="0" g="0" b="0"/>
+          </a:effectRef>
+          <a:fontRef idx="minor"/>
+        </p:style>
+        <p:txBody>
+          <a:bodyPr lIns="90000" tIns="45000" rIns="90000" bIns="45000" anchor="ctr">
+            <a:noAutofit/>
+          </a:bodyPr>
+          <a:lstStyle/>
+          <a:p>
+            <a:pPr algn="r">
+              <a:tabLst>
+                <a:tab pos="0" algn="l"/>
+              </a:tabLst>
+            </a:pPr>
+            <a:r>
+              <a:rPr lang="en-US" sz="1050" b="0" u="none" strike="noStrike" dirty="0" err="1">
+                <a:solidFill>
+                  <a:srgbClr val="757575"/>
+                </a:solidFill>
+                <a:effectLst/>
+                <a:uFillTx/>
+                <a:latin typeface="Arial"/>
+                <a:ea typeface="Arial"/>
+              </a:rPr>
+              <a:t>Despliegue</a:t>
+            </a:r>
+            <a:r>
+              <a:rPr lang="en-US" sz="1050" b="0" u="none" strike="noStrike" dirty="0">
+                <a:solidFill>
+                  <a:srgbClr val="757575"/>
+                </a:solidFill>
+                <a:effectLst/>
+                <a:uFillTx/>
+                <a:latin typeface="Arial"/>
+                <a:ea typeface="Arial"/>
+              </a:rPr>
+              <a:t> de </a:t>
+            </a:r>
+            <a:r>
+              <a:rPr lang="en-US" sz="1050" b="0" u="none" strike="noStrike" dirty="0" err="1">
+                <a:solidFill>
+                  <a:srgbClr val="757575"/>
+                </a:solidFill>
+                <a:effectLst/>
+                <a:uFillTx/>
+                <a:latin typeface="Arial"/>
+                <a:ea typeface="Arial"/>
+              </a:rPr>
+              <a:t>Aplicaciones</a:t>
+            </a:r>
+            <a:r>
+              <a:rPr lang="en-US" sz="1050" b="0" u="none" strike="noStrike" dirty="0">
+                <a:solidFill>
+                  <a:srgbClr val="757575"/>
+                </a:solidFill>
+                <a:effectLst/>
+                <a:uFillTx/>
+                <a:latin typeface="Arial"/>
+                <a:ea typeface="Arial"/>
+              </a:rPr>
+              <a:t> Web — Tema 1: </a:t>
+            </a:r>
+            <a:r>
+              <a:rPr lang="en-US" sz="1050" b="0" u="none" strike="noStrike" dirty="0" err="1">
+                <a:solidFill>
+                  <a:srgbClr val="757575"/>
+                </a:solidFill>
+                <a:effectLst/>
+                <a:uFillTx/>
+                <a:latin typeface="Arial"/>
+                <a:ea typeface="Arial"/>
+              </a:rPr>
+              <a:t>Sesión</a:t>
+            </a:r>
+            <a:r>
+              <a:rPr lang="en-US" sz="1050" b="0" u="none" strike="noStrike" dirty="0">
+                <a:solidFill>
+                  <a:srgbClr val="757575"/>
+                </a:solidFill>
+                <a:effectLst/>
+                <a:uFillTx/>
+                <a:latin typeface="Arial"/>
+                <a:ea typeface="Arial"/>
+              </a:rPr>
+              <a:t> </a:t>
+            </a:r>
+            <a:r>
+              <a:rPr lang="en-US" sz="1050" dirty="0">
+                <a:solidFill>
+                  <a:srgbClr val="757575"/>
+                </a:solidFill>
+                <a:ea typeface="Arial"/>
+              </a:rPr>
+              <a:t>2 — </a:t>
+            </a:r>
+            <a:r>
+              <a:rPr lang="en-US" sz="1050" dirty="0">
+                <a:solidFill>
+                  <a:srgbClr val="757575"/>
+                </a:solidFill>
+                <a:latin typeface="Arial"/>
+                <a:ea typeface="Arial"/>
+              </a:rPr>
+              <a:t>Control de versions y </a:t>
+            </a:r>
+            <a:r>
+              <a:rPr lang="en-US" sz="1050" dirty="0" err="1">
+                <a:solidFill>
+                  <a:srgbClr val="757575"/>
+                </a:solidFill>
+                <a:latin typeface="Arial"/>
+                <a:ea typeface="Arial"/>
+              </a:rPr>
+              <a:t>documentación</a:t>
+            </a:r>
+            <a:endParaRPr lang="en-US" sz="1050" b="0" u="none" strike="noStrike" dirty="0">
+              <a:solidFill>
+                <a:srgbClr val="000000"/>
+              </a:solidFill>
+              <a:effectLst/>
+              <a:uFillTx/>
+              <a:latin typeface="Arial"/>
+            </a:endParaRPr>
+          </a:p>
+        </p:txBody>
+      </p:sp>
+      <p:sp>
+        <p:nvSpPr>
+          <p:cNvPr id="27" name="Text 13">
+            <a:extLst>
+              <a:ext uri="{FF2B5EF4-FFF2-40B4-BE49-F238E27FC236}">
+                <a16:creationId xmlns:a16="http://schemas.microsoft.com/office/drawing/2014/main" id="{618CC1CD-516A-5368-093D-84ED89B3FC2A}"/>
+              </a:ext>
+            </a:extLst>
+          </p:cNvPr>
+          <p:cNvSpPr/>
+          <p:nvPr/>
+        </p:nvSpPr>
+        <p:spPr>
+          <a:xfrm>
+            <a:off x="1353240" y="5596200"/>
+            <a:ext cx="9729000" cy="328680"/>
+          </a:xfrm>
+          <a:prstGeom prst="rect">
+            <a:avLst/>
+          </a:prstGeom>
+          <a:noFill/>
+          <a:ln w="0">
+            <a:noFill/>
+          </a:ln>
+        </p:spPr>
+        <p:style>
+          <a:lnRef idx="0">
+            <a:scrgbClr r="0" g="0" b="0"/>
+          </a:lnRef>
+          <a:fillRef idx="0">
+            <a:scrgbClr r="0" g="0" b="0"/>
+          </a:fillRef>
+          <a:effectRef idx="0">
+            <a:scrgbClr r="0" g="0" b="0"/>
+          </a:effectRef>
+          <a:fontRef idx="minor"/>
+        </p:style>
+        <p:txBody>
+          <a:bodyPr lIns="90000" tIns="45000" rIns="90000" bIns="45000" anchor="ctr">
+            <a:noAutofit/>
+          </a:bodyPr>
+          <a:lstStyle/>
+          <a:p>
+            <a:pPr algn="ctr" defTabSz="457200">
+              <a:lnSpc>
+                <a:spcPct val="100000"/>
+              </a:lnSpc>
+            </a:pPr>
+            <a:r>
+              <a:rPr lang="en-US" dirty="0">
+                <a:solidFill>
+                  <a:srgbClr val="1C3565"/>
+                </a:solidFill>
+                <a:latin typeface="Aptos"/>
+              </a:rPr>
+              <a:t>El </a:t>
+            </a:r>
+            <a:r>
+              <a:rPr lang="en-US" dirty="0" err="1">
+                <a:solidFill>
+                  <a:srgbClr val="1C3565"/>
+                </a:solidFill>
+                <a:latin typeface="Aptos"/>
+              </a:rPr>
+              <a:t>repositorio</a:t>
+            </a:r>
+            <a:r>
+              <a:rPr lang="en-US" dirty="0">
+                <a:solidFill>
+                  <a:srgbClr val="1C3565"/>
+                </a:solidFill>
+                <a:latin typeface="Aptos"/>
+              </a:rPr>
+              <a:t> </a:t>
+            </a:r>
+            <a:r>
+              <a:rPr lang="en-US" dirty="0" err="1">
+                <a:solidFill>
+                  <a:srgbClr val="1C3565"/>
+                </a:solidFill>
+                <a:latin typeface="Aptos"/>
+              </a:rPr>
+              <a:t>debe</a:t>
+            </a:r>
+            <a:r>
+              <a:rPr lang="en-US" dirty="0">
+                <a:solidFill>
+                  <a:srgbClr val="1C3565"/>
+                </a:solidFill>
+                <a:latin typeface="Aptos"/>
+              </a:rPr>
+              <a:t> </a:t>
+            </a:r>
+            <a:r>
+              <a:rPr lang="en-US" dirty="0" err="1">
+                <a:solidFill>
+                  <a:srgbClr val="1C3565"/>
+                </a:solidFill>
+                <a:latin typeface="Aptos"/>
+              </a:rPr>
+              <a:t>explicar</a:t>
+            </a:r>
+            <a:r>
+              <a:rPr lang="en-US" dirty="0">
+                <a:solidFill>
+                  <a:srgbClr val="1C3565"/>
+                </a:solidFill>
+                <a:latin typeface="Aptos"/>
+              </a:rPr>
+              <a:t> </a:t>
+            </a:r>
+            <a:r>
+              <a:rPr lang="en-US" dirty="0" err="1">
+                <a:solidFill>
+                  <a:srgbClr val="1C3565"/>
+                </a:solidFill>
+                <a:latin typeface="Aptos"/>
+              </a:rPr>
+              <a:t>cómo</a:t>
+            </a:r>
+            <a:r>
+              <a:rPr lang="en-US" dirty="0">
+                <a:solidFill>
+                  <a:srgbClr val="1C3565"/>
+                </a:solidFill>
+                <a:latin typeface="Aptos"/>
+              </a:rPr>
+              <a:t> </a:t>
+            </a:r>
+            <a:r>
+              <a:rPr lang="en-US" dirty="0" err="1">
+                <a:solidFill>
+                  <a:srgbClr val="1C3565"/>
+                </a:solidFill>
+                <a:latin typeface="Aptos"/>
+              </a:rPr>
+              <a:t>reconstruir</a:t>
+            </a:r>
+            <a:r>
+              <a:rPr lang="en-US" dirty="0">
+                <a:solidFill>
+                  <a:srgbClr val="1C3565"/>
+                </a:solidFill>
+                <a:latin typeface="Aptos"/>
+              </a:rPr>
+              <a:t> el </a:t>
+            </a:r>
+            <a:r>
+              <a:rPr lang="en-US" dirty="0" err="1">
+                <a:solidFill>
+                  <a:srgbClr val="1C3565"/>
+                </a:solidFill>
+                <a:latin typeface="Aptos"/>
+              </a:rPr>
+              <a:t>despliegue</a:t>
+            </a:r>
+            <a:r>
+              <a:rPr lang="en-US" dirty="0">
+                <a:solidFill>
+                  <a:srgbClr val="1C3565"/>
+                </a:solidFill>
+                <a:latin typeface="Aptos"/>
+              </a:rPr>
+              <a:t>, no </a:t>
+            </a:r>
+            <a:r>
+              <a:rPr lang="en-US" dirty="0" err="1">
+                <a:solidFill>
+                  <a:srgbClr val="1C3565"/>
+                </a:solidFill>
+                <a:latin typeface="Aptos"/>
+              </a:rPr>
+              <a:t>almacenar</a:t>
+            </a:r>
+            <a:r>
+              <a:rPr lang="en-US" dirty="0">
+                <a:solidFill>
+                  <a:srgbClr val="1C3565"/>
+                </a:solidFill>
+                <a:latin typeface="Aptos"/>
+              </a:rPr>
+              <a:t> </a:t>
+            </a:r>
+            <a:r>
+              <a:rPr lang="en-US" dirty="0" err="1">
+                <a:solidFill>
+                  <a:srgbClr val="1C3565"/>
+                </a:solidFill>
+                <a:latin typeface="Aptos"/>
+              </a:rPr>
+              <a:t>datos</a:t>
+            </a:r>
+            <a:r>
+              <a:rPr lang="en-US" dirty="0">
+                <a:solidFill>
+                  <a:srgbClr val="1C3565"/>
+                </a:solidFill>
+                <a:latin typeface="Aptos"/>
+              </a:rPr>
+              <a:t> privados.</a:t>
+            </a:r>
+            <a:endParaRPr lang="en-US" dirty="0">
+              <a:solidFill>
+                <a:srgbClr val="000000"/>
+              </a:solidFill>
+            </a:endParaRPr>
+          </a:p>
+        </p:txBody>
+      </p:sp>
+      <p:sp>
+        <p:nvSpPr>
+          <p:cNvPr id="2" name="Rounded Rectangle 4">
+            <a:extLst>
+              <a:ext uri="{FF2B5EF4-FFF2-40B4-BE49-F238E27FC236}">
+                <a16:creationId xmlns:a16="http://schemas.microsoft.com/office/drawing/2014/main" id="{CD950D08-99FC-411F-AF22-5469039B6608}"/>
+              </a:ext>
+            </a:extLst>
+          </p:cNvPr>
+          <p:cNvSpPr/>
+          <p:nvPr/>
+        </p:nvSpPr>
+        <p:spPr>
+          <a:xfrm>
+            <a:off x="685800" y="1097280"/>
+            <a:ext cx="3291480" cy="2893952"/>
+          </a:xfrm>
+          <a:prstGeom prst="roundRect">
+            <a:avLst>
+              <a:gd name="adj" fmla="val 16667"/>
+            </a:avLst>
+          </a:prstGeom>
+          <a:solidFill>
+            <a:srgbClr val="F2EDFA"/>
+          </a:solidFill>
+          <a:ln>
+            <a:solidFill>
+              <a:srgbClr val="B5CEC4"/>
+            </a:solidFill>
+            <a:round/>
+          </a:ln>
+          <a:effectLst>
+            <a:outerShdw blurRad="39960" dist="23040" dir="5400000" rotWithShape="0">
+              <a:srgbClr val="000000">
+                <a:alpha val="35000"/>
+              </a:srgbClr>
+            </a:outerShdw>
+          </a:effectLst>
+        </p:spPr>
+        <p:style>
+          <a:lnRef idx="1">
+            <a:schemeClr val="accent1"/>
+          </a:lnRef>
+          <a:fillRef idx="3">
+            <a:schemeClr val="accent1"/>
+          </a:fillRef>
+          <a:effectRef idx="2">
+            <a:schemeClr val="accent1"/>
+          </a:effectRef>
+          <a:fontRef idx="minor"/>
+        </p:style>
+        <p:txBody>
+          <a:bodyPr lIns="101520" tIns="481680" rIns="101520" bIns="101520" anchor="t">
+            <a:noAutofit/>
+          </a:bodyPr>
+          <a:lstStyle/>
+          <a:p>
+            <a:pPr marL="285750" indent="-285750" defTabSz="457200">
+              <a:lnSpc>
+                <a:spcPct val="100000"/>
+              </a:lnSpc>
+              <a:spcAft>
+                <a:spcPts val="600"/>
+              </a:spcAft>
+              <a:buFont typeface="Arial" panose="020B0604020202020204" pitchFamily="34" charset="0"/>
+              <a:buChar char="•"/>
+            </a:pPr>
+            <a:r>
+              <a:rPr lang="en-US" sz="1600" b="0" u="none" strike="noStrike" dirty="0" err="1">
+                <a:solidFill>
+                  <a:srgbClr val="2D3436"/>
+                </a:solidFill>
+                <a:effectLst/>
+                <a:uFillTx/>
+              </a:rPr>
+              <a:t>Título</a:t>
+            </a:r>
+            <a:r>
+              <a:rPr lang="en-US" sz="1600" b="0" u="none" strike="noStrike" dirty="0">
+                <a:solidFill>
+                  <a:srgbClr val="2D3436"/>
+                </a:solidFill>
+                <a:effectLst/>
+                <a:uFillTx/>
+              </a:rPr>
+              <a:t> y </a:t>
+            </a:r>
+            <a:r>
+              <a:rPr lang="en-US" sz="1600" b="0" u="none" strike="noStrike" dirty="0" err="1">
+                <a:solidFill>
+                  <a:srgbClr val="2D3436"/>
+                </a:solidFill>
+                <a:effectLst/>
+                <a:uFillTx/>
+              </a:rPr>
+              <a:t>subtítulos</a:t>
+            </a:r>
+            <a:endParaRPr lang="en-US" sz="1600" b="0" u="none" strike="noStrike" dirty="0">
+              <a:solidFill>
+                <a:srgbClr val="000000"/>
+              </a:solidFill>
+              <a:effectLst/>
+              <a:uFillTx/>
+            </a:endParaRPr>
+          </a:p>
+          <a:p>
+            <a:pPr marL="285750" indent="-285750" defTabSz="457200">
+              <a:lnSpc>
+                <a:spcPct val="100000"/>
+              </a:lnSpc>
+              <a:spcAft>
+                <a:spcPts val="600"/>
+              </a:spcAft>
+              <a:buFont typeface="Arial" panose="020B0604020202020204" pitchFamily="34" charset="0"/>
+              <a:buChar char="•"/>
+            </a:pPr>
+            <a:r>
+              <a:rPr lang="en-US" sz="1600" b="0" u="none" strike="noStrike" dirty="0" err="1">
+                <a:solidFill>
+                  <a:srgbClr val="2D3436"/>
+                </a:solidFill>
+                <a:effectLst/>
+                <a:uFillTx/>
+              </a:rPr>
+              <a:t>Listas</a:t>
+            </a:r>
+            <a:endParaRPr lang="en-US" sz="1600" b="0" u="none" strike="noStrike" dirty="0">
+              <a:solidFill>
+                <a:srgbClr val="000000"/>
+              </a:solidFill>
+              <a:effectLst/>
+              <a:uFillTx/>
+            </a:endParaRPr>
+          </a:p>
+          <a:p>
+            <a:pPr marL="285750" indent="-285750" defTabSz="457200">
+              <a:lnSpc>
+                <a:spcPct val="100000"/>
+              </a:lnSpc>
+              <a:spcAft>
+                <a:spcPts val="600"/>
+              </a:spcAft>
+              <a:buFont typeface="Arial" panose="020B0604020202020204" pitchFamily="34" charset="0"/>
+              <a:buChar char="•"/>
+            </a:pPr>
+            <a:r>
+              <a:rPr lang="en-US" sz="1600" b="0" u="none" strike="noStrike" dirty="0">
+                <a:solidFill>
+                  <a:srgbClr val="2D3436"/>
+                </a:solidFill>
+                <a:effectLst/>
+                <a:uFillTx/>
+              </a:rPr>
+              <a:t>Código </a:t>
+            </a:r>
+            <a:r>
+              <a:rPr lang="en-US" sz="1600" b="0" u="none" strike="noStrike" dirty="0" err="1">
+                <a:solidFill>
+                  <a:srgbClr val="2D3436"/>
+                </a:solidFill>
+                <a:effectLst/>
+                <a:uFillTx/>
+              </a:rPr>
+              <a:t>en</a:t>
+            </a:r>
+            <a:r>
+              <a:rPr lang="en-US" sz="1600" b="0" u="none" strike="noStrike" dirty="0">
+                <a:solidFill>
+                  <a:srgbClr val="2D3436"/>
+                </a:solidFill>
+                <a:effectLst/>
+                <a:uFillTx/>
+              </a:rPr>
+              <a:t> </a:t>
+            </a:r>
+            <a:r>
+              <a:rPr lang="en-US" sz="1600" b="0" u="none" strike="noStrike" dirty="0" err="1">
+                <a:solidFill>
+                  <a:srgbClr val="2D3436"/>
+                </a:solidFill>
+                <a:effectLst/>
+                <a:uFillTx/>
+              </a:rPr>
+              <a:t>línea</a:t>
+            </a:r>
+            <a:r>
+              <a:rPr lang="en-US" sz="1600" b="0" u="none" strike="noStrike" dirty="0">
+                <a:solidFill>
+                  <a:srgbClr val="2D3436"/>
+                </a:solidFill>
+                <a:effectLst/>
+                <a:uFillTx/>
+              </a:rPr>
+              <a:t> y </a:t>
+            </a:r>
+            <a:r>
+              <a:rPr lang="en-US" sz="1600" b="0" u="none" strike="noStrike" dirty="0" err="1">
+                <a:solidFill>
+                  <a:srgbClr val="2D3436"/>
+                </a:solidFill>
+                <a:effectLst/>
+                <a:uFillTx/>
+              </a:rPr>
+              <a:t>bloques</a:t>
+            </a:r>
+            <a:endParaRPr lang="en-US" sz="1600" b="0" u="none" strike="noStrike" dirty="0">
+              <a:solidFill>
+                <a:srgbClr val="000000"/>
+              </a:solidFill>
+              <a:effectLst/>
+              <a:uFillTx/>
+            </a:endParaRPr>
+          </a:p>
+          <a:p>
+            <a:pPr marL="285750" indent="-285750" defTabSz="457200">
+              <a:lnSpc>
+                <a:spcPct val="100000"/>
+              </a:lnSpc>
+              <a:spcAft>
+                <a:spcPts val="600"/>
+              </a:spcAft>
+              <a:buFont typeface="Arial" panose="020B0604020202020204" pitchFamily="34" charset="0"/>
+              <a:buChar char="•"/>
+            </a:pPr>
+            <a:r>
+              <a:rPr lang="en-US" sz="1600" b="0" u="none" strike="noStrike" dirty="0">
+                <a:solidFill>
+                  <a:srgbClr val="2D3436"/>
+                </a:solidFill>
+                <a:effectLst/>
+                <a:uFillTx/>
+              </a:rPr>
+              <a:t>Enlaces </a:t>
+            </a:r>
+            <a:r>
+              <a:rPr lang="en-US" sz="1600" b="0" u="none" strike="noStrike" dirty="0" err="1">
+                <a:solidFill>
+                  <a:srgbClr val="2D3436"/>
+                </a:solidFill>
+                <a:effectLst/>
+                <a:uFillTx/>
+              </a:rPr>
+              <a:t>relativos</a:t>
+            </a:r>
+            <a:endParaRPr lang="en-US" sz="1600" b="0" u="none" strike="noStrike" dirty="0">
+              <a:solidFill>
+                <a:srgbClr val="000000"/>
+              </a:solidFill>
+              <a:effectLst/>
+              <a:uFillTx/>
+            </a:endParaRPr>
+          </a:p>
+          <a:p>
+            <a:pPr marL="285750" indent="-285750" defTabSz="457200">
+              <a:lnSpc>
+                <a:spcPct val="100000"/>
+              </a:lnSpc>
+              <a:spcAft>
+                <a:spcPts val="600"/>
+              </a:spcAft>
+              <a:buFont typeface="Arial" panose="020B0604020202020204" pitchFamily="34" charset="0"/>
+              <a:buChar char="•"/>
+            </a:pPr>
+            <a:r>
+              <a:rPr lang="en-US" sz="1600" b="0" u="none" strike="noStrike" dirty="0" err="1">
+                <a:solidFill>
+                  <a:srgbClr val="2D3436"/>
+                </a:solidFill>
+                <a:effectLst/>
+                <a:uFillTx/>
+              </a:rPr>
+              <a:t>Imágenes</a:t>
+            </a:r>
+            <a:endParaRPr lang="en-US" sz="1600" b="0" u="none" strike="noStrike" dirty="0">
+              <a:solidFill>
+                <a:srgbClr val="000000"/>
+              </a:solidFill>
+              <a:effectLst/>
+              <a:uFillTx/>
+            </a:endParaRPr>
+          </a:p>
+        </p:txBody>
+      </p:sp>
+      <p:sp>
+        <p:nvSpPr>
+          <p:cNvPr id="4" name="Rounded Rectangle 5">
+            <a:extLst>
+              <a:ext uri="{FF2B5EF4-FFF2-40B4-BE49-F238E27FC236}">
+                <a16:creationId xmlns:a16="http://schemas.microsoft.com/office/drawing/2014/main" id="{8F366069-E7BC-A6D1-D4CF-177C6AD88855}"/>
+              </a:ext>
+            </a:extLst>
+          </p:cNvPr>
+          <p:cNvSpPr/>
+          <p:nvPr/>
+        </p:nvSpPr>
+        <p:spPr>
+          <a:xfrm>
+            <a:off x="704160" y="1115640"/>
+            <a:ext cx="3254760" cy="381992"/>
+          </a:xfrm>
+          <a:prstGeom prst="roundRect">
+            <a:avLst>
+              <a:gd name="adj" fmla="val 16667"/>
+            </a:avLst>
+          </a:prstGeom>
+          <a:solidFill>
+            <a:srgbClr val="8B5CF6"/>
+          </a:solidFill>
+          <a:ln>
+            <a:solidFill>
+              <a:srgbClr val="8B5CF6"/>
+            </a:solidFill>
+            <a:round/>
+          </a:ln>
+          <a:effectLst>
+            <a:outerShdw blurRad="39960" dist="23040" dir="5400000" rotWithShape="0">
+              <a:srgbClr val="000000">
+                <a:alpha val="35000"/>
+              </a:srgbClr>
+            </a:outerShdw>
+          </a:effectLst>
+        </p:spPr>
+        <p:style>
+          <a:lnRef idx="1">
+            <a:schemeClr val="accent1"/>
+          </a:lnRef>
+          <a:fillRef idx="3">
+            <a:schemeClr val="accent1"/>
+          </a:fillRef>
+          <a:effectRef idx="2">
+            <a:schemeClr val="accent1"/>
+          </a:effectRef>
+          <a:fontRef idx="minor"/>
+        </p:style>
+        <p:txBody>
+          <a:bodyPr lIns="90000" tIns="45000" rIns="90000" bIns="45000" anchor="ctr">
+            <a:noAutofit/>
+          </a:bodyPr>
+          <a:lstStyle/>
+          <a:p>
+            <a:pPr defTabSz="457200">
+              <a:lnSpc>
+                <a:spcPct val="100000"/>
+              </a:lnSpc>
+            </a:pPr>
+            <a:endParaRPr lang="en-US" sz="1600" b="0" u="none" strike="noStrike">
+              <a:solidFill>
+                <a:schemeClr val="lt1"/>
+              </a:solidFill>
+              <a:effectLst/>
+              <a:uFillTx/>
+            </a:endParaRPr>
+          </a:p>
+        </p:txBody>
+      </p:sp>
+      <p:sp>
+        <p:nvSpPr>
+          <p:cNvPr id="5" name="TextBox 6">
+            <a:extLst>
+              <a:ext uri="{FF2B5EF4-FFF2-40B4-BE49-F238E27FC236}">
+                <a16:creationId xmlns:a16="http://schemas.microsoft.com/office/drawing/2014/main" id="{301B0975-E141-44C0-399B-0B794190B44E}"/>
+              </a:ext>
+            </a:extLst>
+          </p:cNvPr>
+          <p:cNvSpPr/>
+          <p:nvPr/>
+        </p:nvSpPr>
+        <p:spPr>
+          <a:xfrm>
+            <a:off x="758880" y="1088805"/>
+            <a:ext cx="3145320" cy="400352"/>
+          </a:xfrm>
+          <a:prstGeom prst="rect">
+            <a:avLst/>
+          </a:prstGeom>
+          <a:noFill/>
+          <a:ln w="0">
+            <a:noFill/>
+          </a:ln>
+        </p:spPr>
+        <p:style>
+          <a:lnRef idx="0">
+            <a:scrgbClr r="0" g="0" b="0"/>
+          </a:lnRef>
+          <a:fillRef idx="0">
+            <a:scrgbClr r="0" g="0" b="0"/>
+          </a:fillRef>
+          <a:effectRef idx="0">
+            <a:scrgbClr r="0" g="0" b="0"/>
+          </a:effectRef>
+          <a:fontRef idx="minor"/>
+        </p:style>
+        <p:txBody>
+          <a:bodyPr lIns="76320" tIns="76320" rIns="76320" bIns="76320" anchor="ctr">
+            <a:spAutoFit/>
+          </a:bodyPr>
+          <a:lstStyle/>
+          <a:p>
+            <a:pPr defTabSz="457200">
+              <a:lnSpc>
+                <a:spcPct val="100000"/>
+              </a:lnSpc>
+            </a:pPr>
+            <a:r>
+              <a:rPr lang="en-US" sz="1600" b="1" u="none" strike="noStrike">
+                <a:solidFill>
+                  <a:srgbClr val="FFFFFF"/>
+                </a:solidFill>
+                <a:effectLst/>
+                <a:uFillTx/>
+              </a:rPr>
+              <a:t>Markdown esencial</a:t>
+            </a:r>
+            <a:endParaRPr lang="en-US" sz="1600" b="0" u="none" strike="noStrike">
+              <a:solidFill>
+                <a:srgbClr val="000000"/>
+              </a:solidFill>
+              <a:effectLst/>
+              <a:uFillTx/>
+            </a:endParaRPr>
+          </a:p>
+        </p:txBody>
+      </p:sp>
+      <p:sp>
+        <p:nvSpPr>
+          <p:cNvPr id="7" name="Rounded Rectangle 7">
+            <a:extLst>
+              <a:ext uri="{FF2B5EF4-FFF2-40B4-BE49-F238E27FC236}">
+                <a16:creationId xmlns:a16="http://schemas.microsoft.com/office/drawing/2014/main" id="{8DEBA676-3696-16D0-52AD-17D9184C6843}"/>
+              </a:ext>
+            </a:extLst>
+          </p:cNvPr>
+          <p:cNvSpPr/>
+          <p:nvPr/>
+        </p:nvSpPr>
+        <p:spPr>
+          <a:xfrm>
+            <a:off x="4434840" y="1097280"/>
+            <a:ext cx="3291480" cy="2893952"/>
+          </a:xfrm>
+          <a:prstGeom prst="roundRect">
+            <a:avLst>
+              <a:gd name="adj" fmla="val 16667"/>
+            </a:avLst>
+          </a:prstGeom>
+          <a:solidFill>
+            <a:srgbClr val="E6F4EF"/>
+          </a:solidFill>
+          <a:ln>
+            <a:solidFill>
+              <a:srgbClr val="B5CEC4"/>
+            </a:solidFill>
+            <a:round/>
+          </a:ln>
+          <a:effectLst>
+            <a:outerShdw blurRad="39960" dist="23040" dir="5400000" rotWithShape="0">
+              <a:srgbClr val="000000">
+                <a:alpha val="35000"/>
+              </a:srgbClr>
+            </a:outerShdw>
+          </a:effectLst>
+        </p:spPr>
+        <p:style>
+          <a:lnRef idx="1">
+            <a:schemeClr val="accent1"/>
+          </a:lnRef>
+          <a:fillRef idx="3">
+            <a:schemeClr val="accent1"/>
+          </a:fillRef>
+          <a:effectRef idx="2">
+            <a:schemeClr val="accent1"/>
+          </a:effectRef>
+          <a:fontRef idx="minor"/>
+        </p:style>
+        <p:txBody>
+          <a:bodyPr lIns="101520" tIns="481680" rIns="101520" bIns="101520" anchor="t">
+            <a:noAutofit/>
+          </a:bodyPr>
+          <a:lstStyle/>
+          <a:p>
+            <a:pPr marL="285750" indent="-285750" defTabSz="457200">
+              <a:lnSpc>
+                <a:spcPct val="100000"/>
+              </a:lnSpc>
+              <a:spcAft>
+                <a:spcPts val="600"/>
+              </a:spcAft>
+              <a:buFont typeface="Arial" panose="020B0604020202020204" pitchFamily="34" charset="0"/>
+              <a:buChar char="•"/>
+            </a:pPr>
+            <a:r>
+              <a:rPr lang="en-US" sz="1600" b="0" u="none" strike="noStrike" dirty="0" err="1">
+                <a:solidFill>
+                  <a:srgbClr val="2D3436"/>
+                </a:solidFill>
+                <a:effectLst/>
+                <a:uFillTx/>
+              </a:rPr>
+              <a:t>Qué</a:t>
+            </a:r>
+            <a:r>
+              <a:rPr lang="en-US" sz="1600" b="0" u="none" strike="noStrike" dirty="0">
+                <a:solidFill>
+                  <a:srgbClr val="2D3436"/>
+                </a:solidFill>
+                <a:effectLst/>
+                <a:uFillTx/>
+              </a:rPr>
+              <a:t> es el </a:t>
+            </a:r>
+            <a:r>
+              <a:rPr lang="en-US" sz="1600" b="0" u="none" strike="noStrike" dirty="0" err="1">
+                <a:solidFill>
+                  <a:srgbClr val="2D3436"/>
+                </a:solidFill>
+                <a:effectLst/>
+                <a:uFillTx/>
+              </a:rPr>
+              <a:t>proyecto</a:t>
+            </a:r>
+            <a:endParaRPr lang="en-US" sz="1600" b="0" u="none" strike="noStrike" dirty="0">
+              <a:solidFill>
+                <a:srgbClr val="000000"/>
+              </a:solidFill>
+              <a:effectLst/>
+              <a:uFillTx/>
+            </a:endParaRPr>
+          </a:p>
+          <a:p>
+            <a:pPr marL="285750" indent="-285750" defTabSz="457200">
+              <a:lnSpc>
+                <a:spcPct val="100000"/>
+              </a:lnSpc>
+              <a:spcAft>
+                <a:spcPts val="600"/>
+              </a:spcAft>
+              <a:buFont typeface="Arial" panose="020B0604020202020204" pitchFamily="34" charset="0"/>
+              <a:buChar char="•"/>
+            </a:pPr>
+            <a:r>
+              <a:rPr lang="en-US" sz="1600" b="0" u="none" strike="noStrike" dirty="0" err="1">
+                <a:solidFill>
+                  <a:srgbClr val="2D3436"/>
+                </a:solidFill>
+                <a:effectLst/>
+                <a:uFillTx/>
+              </a:rPr>
+              <a:t>Requisitos</a:t>
+            </a:r>
+            <a:endParaRPr lang="en-US" sz="1600" b="0" u="none" strike="noStrike" dirty="0">
+              <a:solidFill>
+                <a:srgbClr val="000000"/>
+              </a:solidFill>
+              <a:effectLst/>
+              <a:uFillTx/>
+            </a:endParaRPr>
+          </a:p>
+          <a:p>
+            <a:pPr marL="285750" indent="-285750" defTabSz="457200">
+              <a:lnSpc>
+                <a:spcPct val="100000"/>
+              </a:lnSpc>
+              <a:spcAft>
+                <a:spcPts val="600"/>
+              </a:spcAft>
+              <a:buFont typeface="Arial" panose="020B0604020202020204" pitchFamily="34" charset="0"/>
+              <a:buChar char="•"/>
+            </a:pPr>
+            <a:r>
+              <a:rPr lang="en-US" sz="1600" b="0" u="none" strike="noStrike" dirty="0" err="1">
+                <a:solidFill>
+                  <a:srgbClr val="2D3436"/>
+                </a:solidFill>
+                <a:effectLst/>
+                <a:uFillTx/>
+              </a:rPr>
+              <a:t>Estructura</a:t>
+            </a:r>
+            <a:r>
+              <a:rPr lang="en-US" sz="1600" b="0" u="none" strike="noStrike" dirty="0">
+                <a:solidFill>
+                  <a:srgbClr val="2D3436"/>
+                </a:solidFill>
+                <a:effectLst/>
+                <a:uFillTx/>
+              </a:rPr>
+              <a:t> del </a:t>
+            </a:r>
+            <a:r>
+              <a:rPr lang="en-US" sz="1600" b="0" u="none" strike="noStrike" dirty="0" err="1">
+                <a:solidFill>
+                  <a:srgbClr val="2D3436"/>
+                </a:solidFill>
+                <a:effectLst/>
+                <a:uFillTx/>
+              </a:rPr>
+              <a:t>repositorio</a:t>
+            </a:r>
+            <a:endParaRPr lang="en-US" sz="1600" b="0" u="none" strike="noStrike" dirty="0">
+              <a:solidFill>
+                <a:srgbClr val="000000"/>
+              </a:solidFill>
+              <a:effectLst/>
+              <a:uFillTx/>
+            </a:endParaRPr>
+          </a:p>
+          <a:p>
+            <a:pPr marL="285750" indent="-285750" defTabSz="457200">
+              <a:lnSpc>
+                <a:spcPct val="100000"/>
+              </a:lnSpc>
+              <a:spcAft>
+                <a:spcPts val="600"/>
+              </a:spcAft>
+              <a:buFont typeface="Arial" panose="020B0604020202020204" pitchFamily="34" charset="0"/>
+              <a:buChar char="•"/>
+            </a:pPr>
+            <a:r>
+              <a:rPr lang="en-US" sz="1600" b="0" u="none" strike="noStrike" dirty="0" err="1">
+                <a:solidFill>
+                  <a:srgbClr val="2D3436"/>
+                </a:solidFill>
+                <a:effectLst/>
+                <a:uFillTx/>
+              </a:rPr>
+              <a:t>Flujo</a:t>
+            </a:r>
+            <a:r>
+              <a:rPr lang="en-US" sz="1600" b="0" u="none" strike="noStrike" dirty="0">
+                <a:solidFill>
+                  <a:srgbClr val="2D3436"/>
+                </a:solidFill>
+                <a:effectLst/>
+                <a:uFillTx/>
+              </a:rPr>
+              <a:t> de </a:t>
+            </a:r>
+            <a:r>
+              <a:rPr lang="en-US" sz="1600" b="0" u="none" strike="noStrike" dirty="0" err="1">
+                <a:solidFill>
+                  <a:srgbClr val="2D3436"/>
+                </a:solidFill>
+                <a:effectLst/>
+                <a:uFillTx/>
+              </a:rPr>
+              <a:t>trabajo</a:t>
+            </a:r>
+            <a:endParaRPr lang="en-US" sz="1600" b="0" u="none" strike="noStrike" dirty="0">
+              <a:solidFill>
+                <a:srgbClr val="000000"/>
+              </a:solidFill>
+              <a:effectLst/>
+              <a:uFillTx/>
+            </a:endParaRPr>
+          </a:p>
+          <a:p>
+            <a:pPr marL="285750" indent="-285750" defTabSz="457200">
+              <a:lnSpc>
+                <a:spcPct val="100000"/>
+              </a:lnSpc>
+              <a:spcAft>
+                <a:spcPts val="600"/>
+              </a:spcAft>
+              <a:buFont typeface="Arial" panose="020B0604020202020204" pitchFamily="34" charset="0"/>
+              <a:buChar char="•"/>
+            </a:pPr>
+            <a:r>
+              <a:rPr lang="en-US" sz="1600" b="0" u="none" strike="noStrike" dirty="0" err="1">
+                <a:solidFill>
+                  <a:srgbClr val="2D3436"/>
+                </a:solidFill>
+                <a:effectLst/>
+                <a:uFillTx/>
+              </a:rPr>
+              <a:t>Puesta</a:t>
+            </a:r>
+            <a:r>
+              <a:rPr lang="en-US" sz="1600" b="0" u="none" strike="noStrike" dirty="0">
+                <a:solidFill>
+                  <a:srgbClr val="2D3436"/>
+                </a:solidFill>
+                <a:effectLst/>
+                <a:uFillTx/>
+              </a:rPr>
+              <a:t> </a:t>
+            </a:r>
+            <a:r>
+              <a:rPr lang="en-US" sz="1600" b="0" u="none" strike="noStrike" dirty="0" err="1">
+                <a:solidFill>
+                  <a:srgbClr val="2D3436"/>
+                </a:solidFill>
+                <a:effectLst/>
+                <a:uFillTx/>
+              </a:rPr>
+              <a:t>en</a:t>
+            </a:r>
+            <a:r>
+              <a:rPr lang="en-US" sz="1600" b="0" u="none" strike="noStrike" dirty="0">
+                <a:solidFill>
+                  <a:srgbClr val="2D3436"/>
+                </a:solidFill>
+                <a:effectLst/>
+                <a:uFillTx/>
+              </a:rPr>
+              <a:t> </a:t>
+            </a:r>
+            <a:r>
+              <a:rPr lang="en-US" sz="1600" b="0" u="none" strike="noStrike" dirty="0" err="1">
+                <a:solidFill>
+                  <a:srgbClr val="2D3436"/>
+                </a:solidFill>
+                <a:effectLst/>
+                <a:uFillTx/>
+              </a:rPr>
+              <a:t>marcha</a:t>
+            </a:r>
+            <a:r>
+              <a:rPr lang="en-US" sz="1600" b="0" u="none" strike="noStrike" dirty="0">
+                <a:solidFill>
+                  <a:srgbClr val="2D3436"/>
+                </a:solidFill>
+                <a:effectLst/>
+                <a:uFillTx/>
+              </a:rPr>
+              <a:t> y </a:t>
+            </a:r>
+            <a:r>
+              <a:rPr lang="en-US" sz="1600" b="0" u="none" strike="noStrike" dirty="0" err="1">
+                <a:solidFill>
+                  <a:srgbClr val="2D3436"/>
+                </a:solidFill>
+                <a:effectLst/>
+                <a:uFillTx/>
+              </a:rPr>
+              <a:t>comprobación</a:t>
+            </a:r>
+            <a:endParaRPr lang="en-US" sz="1600" b="0" u="none" strike="noStrike" dirty="0">
+              <a:solidFill>
+                <a:srgbClr val="000000"/>
+              </a:solidFill>
+              <a:effectLst/>
+              <a:uFillTx/>
+            </a:endParaRPr>
+          </a:p>
+        </p:txBody>
+      </p:sp>
+      <p:sp>
+        <p:nvSpPr>
+          <p:cNvPr id="8" name="Rounded Rectangle 8">
+            <a:extLst>
+              <a:ext uri="{FF2B5EF4-FFF2-40B4-BE49-F238E27FC236}">
+                <a16:creationId xmlns:a16="http://schemas.microsoft.com/office/drawing/2014/main" id="{ACA81D85-3AE5-AD84-7080-173036D5F02D}"/>
+              </a:ext>
+            </a:extLst>
+          </p:cNvPr>
+          <p:cNvSpPr/>
+          <p:nvPr/>
+        </p:nvSpPr>
+        <p:spPr>
+          <a:xfrm>
+            <a:off x="4453200" y="1115640"/>
+            <a:ext cx="3254760" cy="381992"/>
+          </a:xfrm>
+          <a:prstGeom prst="roundRect">
+            <a:avLst>
+              <a:gd name="adj" fmla="val 16667"/>
+            </a:avLst>
+          </a:prstGeom>
+          <a:solidFill>
+            <a:srgbClr val="228B5E"/>
+          </a:solidFill>
+          <a:ln>
+            <a:solidFill>
+              <a:srgbClr val="228B5E"/>
+            </a:solidFill>
+            <a:round/>
+          </a:ln>
+          <a:effectLst>
+            <a:outerShdw blurRad="39960" dist="23040" dir="5400000" rotWithShape="0">
+              <a:srgbClr val="000000">
+                <a:alpha val="35000"/>
+              </a:srgbClr>
+            </a:outerShdw>
+          </a:effectLst>
+        </p:spPr>
+        <p:style>
+          <a:lnRef idx="1">
+            <a:schemeClr val="accent1"/>
+          </a:lnRef>
+          <a:fillRef idx="3">
+            <a:schemeClr val="accent1"/>
+          </a:fillRef>
+          <a:effectRef idx="2">
+            <a:schemeClr val="accent1"/>
+          </a:effectRef>
+          <a:fontRef idx="minor"/>
+        </p:style>
+        <p:txBody>
+          <a:bodyPr lIns="90000" tIns="45000" rIns="90000" bIns="45000" anchor="ctr">
+            <a:noAutofit/>
+          </a:bodyPr>
+          <a:lstStyle/>
+          <a:p>
+            <a:pPr defTabSz="457200">
+              <a:lnSpc>
+                <a:spcPct val="100000"/>
+              </a:lnSpc>
+            </a:pPr>
+            <a:endParaRPr lang="en-US" sz="1600" b="0" u="none" strike="noStrike">
+              <a:solidFill>
+                <a:schemeClr val="lt1"/>
+              </a:solidFill>
+              <a:effectLst/>
+              <a:uFillTx/>
+            </a:endParaRPr>
+          </a:p>
+        </p:txBody>
+      </p:sp>
+      <p:sp>
+        <p:nvSpPr>
+          <p:cNvPr id="11" name="TextBox 9">
+            <a:extLst>
+              <a:ext uri="{FF2B5EF4-FFF2-40B4-BE49-F238E27FC236}">
+                <a16:creationId xmlns:a16="http://schemas.microsoft.com/office/drawing/2014/main" id="{F421ED78-C055-DE29-C1E6-F68C0601F79E}"/>
+              </a:ext>
+            </a:extLst>
+          </p:cNvPr>
+          <p:cNvSpPr/>
+          <p:nvPr/>
+        </p:nvSpPr>
+        <p:spPr>
+          <a:xfrm>
+            <a:off x="4507920" y="1088805"/>
+            <a:ext cx="3145320" cy="400352"/>
+          </a:xfrm>
+          <a:prstGeom prst="rect">
+            <a:avLst/>
+          </a:prstGeom>
+          <a:noFill/>
+          <a:ln w="0">
+            <a:noFill/>
+          </a:ln>
+        </p:spPr>
+        <p:style>
+          <a:lnRef idx="0">
+            <a:scrgbClr r="0" g="0" b="0"/>
+          </a:lnRef>
+          <a:fillRef idx="0">
+            <a:scrgbClr r="0" g="0" b="0"/>
+          </a:fillRef>
+          <a:effectRef idx="0">
+            <a:scrgbClr r="0" g="0" b="0"/>
+          </a:effectRef>
+          <a:fontRef idx="minor"/>
+        </p:style>
+        <p:txBody>
+          <a:bodyPr lIns="76320" tIns="76320" rIns="76320" bIns="76320" anchor="ctr">
+            <a:spAutoFit/>
+          </a:bodyPr>
+          <a:lstStyle/>
+          <a:p>
+            <a:pPr defTabSz="457200">
+              <a:lnSpc>
+                <a:spcPct val="100000"/>
+              </a:lnSpc>
+            </a:pPr>
+            <a:r>
+              <a:rPr lang="en-US" sz="1600" b="1" u="none" strike="noStrike">
+                <a:solidFill>
+                  <a:srgbClr val="FFFFFF"/>
+                </a:solidFill>
+                <a:effectLst/>
+                <a:uFillTx/>
+              </a:rPr>
+              <a:t>README útil</a:t>
+            </a:r>
+            <a:endParaRPr lang="en-US" sz="1600" b="0" u="none" strike="noStrike">
+              <a:solidFill>
+                <a:srgbClr val="000000"/>
+              </a:solidFill>
+              <a:effectLst/>
+              <a:uFillTx/>
+            </a:endParaRPr>
+          </a:p>
+        </p:txBody>
+      </p:sp>
+      <p:sp>
+        <p:nvSpPr>
+          <p:cNvPr id="12" name="Rounded Rectangle 10">
+            <a:extLst>
+              <a:ext uri="{FF2B5EF4-FFF2-40B4-BE49-F238E27FC236}">
+                <a16:creationId xmlns:a16="http://schemas.microsoft.com/office/drawing/2014/main" id="{4D90553F-9974-0CAD-82D9-2627C994090D}"/>
+              </a:ext>
+            </a:extLst>
+          </p:cNvPr>
+          <p:cNvSpPr/>
+          <p:nvPr/>
+        </p:nvSpPr>
+        <p:spPr>
+          <a:xfrm>
+            <a:off x="8183880" y="1097280"/>
+            <a:ext cx="3291480" cy="2893952"/>
+          </a:xfrm>
+          <a:prstGeom prst="roundRect">
+            <a:avLst>
+              <a:gd name="adj" fmla="val 16667"/>
+            </a:avLst>
+          </a:prstGeom>
+          <a:solidFill>
+            <a:srgbClr val="FCEBE9"/>
+          </a:solidFill>
+          <a:ln>
+            <a:solidFill>
+              <a:srgbClr val="B5CEC4"/>
+            </a:solidFill>
+            <a:round/>
+          </a:ln>
+          <a:effectLst>
+            <a:outerShdw blurRad="39960" dist="23040" dir="5400000" rotWithShape="0">
+              <a:srgbClr val="000000">
+                <a:alpha val="35000"/>
+              </a:srgbClr>
+            </a:outerShdw>
+          </a:effectLst>
+        </p:spPr>
+        <p:style>
+          <a:lnRef idx="1">
+            <a:schemeClr val="accent1"/>
+          </a:lnRef>
+          <a:fillRef idx="3">
+            <a:schemeClr val="accent1"/>
+          </a:fillRef>
+          <a:effectRef idx="2">
+            <a:schemeClr val="accent1"/>
+          </a:effectRef>
+          <a:fontRef idx="minor"/>
+        </p:style>
+        <p:txBody>
+          <a:bodyPr lIns="101520" tIns="481680" rIns="101520" bIns="101520" anchor="t">
+            <a:noAutofit/>
+          </a:bodyPr>
+          <a:lstStyle/>
+          <a:p>
+            <a:pPr marL="285750" indent="-285750" defTabSz="457200">
+              <a:lnSpc>
+                <a:spcPct val="100000"/>
+              </a:lnSpc>
+              <a:spcAft>
+                <a:spcPts val="600"/>
+              </a:spcAft>
+              <a:buFont typeface="Arial" panose="020B0604020202020204" pitchFamily="34" charset="0"/>
+              <a:buChar char="•"/>
+            </a:pPr>
+            <a:r>
+              <a:rPr lang="en-US" sz="1600" b="0" u="none" strike="noStrike" dirty="0">
+                <a:solidFill>
+                  <a:srgbClr val="2D3436"/>
+                </a:solidFill>
+                <a:effectLst/>
+                <a:uFillTx/>
+              </a:rPr>
+              <a:t>Rutas </a:t>
+            </a:r>
+            <a:r>
+              <a:rPr lang="en-US" sz="1600" b="0" u="none" strike="noStrike" dirty="0" err="1">
+                <a:solidFill>
+                  <a:srgbClr val="2D3436"/>
+                </a:solidFill>
+                <a:effectLst/>
+                <a:uFillTx/>
+              </a:rPr>
+              <a:t>absolutas</a:t>
+            </a:r>
+            <a:r>
+              <a:rPr lang="en-US" sz="1600" b="0" u="none" strike="noStrike" dirty="0">
+                <a:solidFill>
+                  <a:srgbClr val="2D3436"/>
+                </a:solidFill>
+                <a:effectLst/>
+                <a:uFillTx/>
+              </a:rPr>
+              <a:t> de </a:t>
+            </a:r>
+            <a:r>
+              <a:rPr lang="en-US" sz="1600" b="0" u="none" strike="noStrike" dirty="0" err="1">
+                <a:solidFill>
+                  <a:srgbClr val="2D3436"/>
+                </a:solidFill>
+                <a:effectLst/>
+                <a:uFillTx/>
+              </a:rPr>
+              <a:t>tu</a:t>
+            </a:r>
+            <a:r>
+              <a:rPr lang="en-US" sz="1600" b="0" u="none" strike="noStrike" dirty="0">
+                <a:solidFill>
+                  <a:srgbClr val="2D3436"/>
+                </a:solidFill>
+                <a:effectLst/>
+                <a:uFillTx/>
+              </a:rPr>
+              <a:t> </a:t>
+            </a:r>
+            <a:r>
+              <a:rPr lang="en-US" sz="1600" b="0" u="none" strike="noStrike" dirty="0" err="1">
+                <a:solidFill>
+                  <a:srgbClr val="2D3436"/>
+                </a:solidFill>
+                <a:effectLst/>
+                <a:uFillTx/>
+              </a:rPr>
+              <a:t>equipo</a:t>
+            </a:r>
+            <a:endParaRPr lang="en-US" sz="1600" b="0" u="none" strike="noStrike" dirty="0">
+              <a:solidFill>
+                <a:srgbClr val="000000"/>
+              </a:solidFill>
+              <a:effectLst/>
+              <a:uFillTx/>
+            </a:endParaRPr>
+          </a:p>
+          <a:p>
+            <a:pPr marL="285750" indent="-285750" defTabSz="457200">
+              <a:lnSpc>
+                <a:spcPct val="100000"/>
+              </a:lnSpc>
+              <a:spcAft>
+                <a:spcPts val="600"/>
+              </a:spcAft>
+              <a:buFont typeface="Arial" panose="020B0604020202020204" pitchFamily="34" charset="0"/>
+              <a:buChar char="•"/>
+            </a:pPr>
+            <a:r>
+              <a:rPr lang="en-US" sz="1600" b="0" u="none" strike="noStrike" dirty="0" err="1">
+                <a:solidFill>
+                  <a:srgbClr val="2D3436"/>
+                </a:solidFill>
+                <a:effectLst/>
+                <a:uFillTx/>
+              </a:rPr>
+              <a:t>Copiar</a:t>
+            </a:r>
+            <a:r>
+              <a:rPr lang="en-US" sz="1600" b="0" u="none" strike="noStrike" dirty="0">
+                <a:solidFill>
+                  <a:srgbClr val="2D3436"/>
+                </a:solidFill>
+                <a:effectLst/>
+                <a:uFillTx/>
+              </a:rPr>
+              <a:t> YAML o compose </a:t>
+            </a:r>
+            <a:r>
+              <a:rPr lang="en-US" sz="1600" b="0" u="none" strike="noStrike" dirty="0" err="1">
+                <a:solidFill>
+                  <a:srgbClr val="2D3436"/>
+                </a:solidFill>
+                <a:effectLst/>
+                <a:uFillTx/>
+              </a:rPr>
+              <a:t>en</a:t>
+            </a:r>
+            <a:r>
+              <a:rPr lang="en-US" sz="1600" b="0" u="none" strike="noStrike" dirty="0">
+                <a:solidFill>
+                  <a:srgbClr val="2D3436"/>
+                </a:solidFill>
+                <a:effectLst/>
+                <a:uFillTx/>
+              </a:rPr>
+              <a:t> </a:t>
+            </a:r>
+            <a:r>
+              <a:rPr lang="en-US" sz="1600" b="0" u="none" strike="noStrike" dirty="0" err="1">
+                <a:solidFill>
+                  <a:srgbClr val="2D3436"/>
+                </a:solidFill>
+                <a:effectLst/>
+                <a:uFillTx/>
+              </a:rPr>
+              <a:t>varios</a:t>
+            </a:r>
+            <a:r>
+              <a:rPr lang="en-US" sz="1600" b="0" u="none" strike="noStrike" dirty="0">
+                <a:solidFill>
+                  <a:srgbClr val="2D3436"/>
+                </a:solidFill>
+                <a:effectLst/>
+                <a:uFillTx/>
+              </a:rPr>
+              <a:t> </a:t>
+            </a:r>
+            <a:r>
+              <a:rPr lang="en-US" sz="1600" b="0" u="none" strike="noStrike" dirty="0" err="1">
+                <a:solidFill>
+                  <a:srgbClr val="2D3436"/>
+                </a:solidFill>
+                <a:effectLst/>
+                <a:uFillTx/>
+              </a:rPr>
+              <a:t>lugares</a:t>
+            </a:r>
+            <a:endParaRPr lang="en-US" sz="1600" b="0" u="none" strike="noStrike" dirty="0">
+              <a:solidFill>
+                <a:srgbClr val="000000"/>
+              </a:solidFill>
+              <a:effectLst/>
+              <a:uFillTx/>
+            </a:endParaRPr>
+          </a:p>
+          <a:p>
+            <a:pPr marL="285750" indent="-285750" defTabSz="457200">
+              <a:lnSpc>
+                <a:spcPct val="100000"/>
+              </a:lnSpc>
+              <a:spcAft>
+                <a:spcPts val="600"/>
+              </a:spcAft>
+              <a:buFont typeface="Arial" panose="020B0604020202020204" pitchFamily="34" charset="0"/>
+              <a:buChar char="•"/>
+            </a:pPr>
+            <a:r>
+              <a:rPr lang="en-US" sz="1600" b="0" u="none" strike="noStrike" dirty="0" err="1">
+                <a:solidFill>
+                  <a:srgbClr val="2D3436"/>
+                </a:solidFill>
+                <a:effectLst/>
+                <a:uFillTx/>
+              </a:rPr>
+              <a:t>Guardar</a:t>
+            </a:r>
+            <a:r>
+              <a:rPr lang="en-US" sz="1600" b="0" u="none" strike="noStrike" dirty="0">
+                <a:solidFill>
+                  <a:srgbClr val="2D3436"/>
+                </a:solidFill>
+                <a:effectLst/>
+                <a:uFillTx/>
+              </a:rPr>
+              <a:t> PAT, claves o </a:t>
+            </a:r>
+            <a:r>
+              <a:rPr lang="en-US" sz="1600" b="0" u="none" strike="noStrike" dirty="0" err="1">
+                <a:solidFill>
+                  <a:srgbClr val="2D3436"/>
+                </a:solidFill>
+                <a:effectLst/>
+                <a:uFillTx/>
+              </a:rPr>
+              <a:t>secretos</a:t>
+            </a:r>
+            <a:endParaRPr lang="en-US" sz="1600" b="0" u="none" strike="noStrike" dirty="0">
+              <a:solidFill>
+                <a:srgbClr val="000000"/>
+              </a:solidFill>
+              <a:effectLst/>
+              <a:uFillTx/>
+            </a:endParaRPr>
+          </a:p>
+          <a:p>
+            <a:pPr marL="285750" indent="-285750" defTabSz="457200">
+              <a:lnSpc>
+                <a:spcPct val="100000"/>
+              </a:lnSpc>
+              <a:spcAft>
+                <a:spcPts val="600"/>
+              </a:spcAft>
+              <a:buFont typeface="Arial" panose="020B0604020202020204" pitchFamily="34" charset="0"/>
+              <a:buChar char="•"/>
+            </a:pPr>
+            <a:r>
+              <a:rPr lang="en-US" sz="1600" b="0" u="none" strike="noStrike" dirty="0" err="1">
+                <a:solidFill>
+                  <a:srgbClr val="2D3436"/>
+                </a:solidFill>
+                <a:effectLst/>
+                <a:uFillTx/>
+              </a:rPr>
+              <a:t>Convertir</a:t>
+            </a:r>
+            <a:r>
+              <a:rPr lang="en-US" sz="1600" b="0" u="none" strike="noStrike" dirty="0">
+                <a:solidFill>
+                  <a:srgbClr val="2D3436"/>
+                </a:solidFill>
+                <a:effectLst/>
+                <a:uFillTx/>
+              </a:rPr>
+              <a:t> el README </a:t>
+            </a:r>
+            <a:r>
+              <a:rPr lang="en-US" sz="1600" b="0" u="none" strike="noStrike" dirty="0" err="1">
+                <a:solidFill>
+                  <a:srgbClr val="2D3436"/>
+                </a:solidFill>
+                <a:effectLst/>
+                <a:uFillTx/>
+              </a:rPr>
+              <a:t>en</a:t>
+            </a:r>
+            <a:r>
+              <a:rPr lang="en-US" sz="1600" b="0" u="none" strike="noStrike" dirty="0">
+                <a:solidFill>
+                  <a:srgbClr val="2D3436"/>
+                </a:solidFill>
+                <a:effectLst/>
+                <a:uFillTx/>
+              </a:rPr>
+              <a:t> un </a:t>
+            </a:r>
+            <a:r>
+              <a:rPr lang="en-US" sz="1600" b="0" u="none" strike="noStrike" dirty="0" err="1">
+                <a:solidFill>
+                  <a:srgbClr val="2D3436"/>
+                </a:solidFill>
+                <a:effectLst/>
+                <a:uFillTx/>
+              </a:rPr>
+              <a:t>diario</a:t>
+            </a:r>
+            <a:endParaRPr lang="en-US" sz="1600" b="0" u="none" strike="noStrike" dirty="0">
+              <a:solidFill>
+                <a:srgbClr val="000000"/>
+              </a:solidFill>
+              <a:effectLst/>
+              <a:uFillTx/>
+            </a:endParaRPr>
+          </a:p>
+        </p:txBody>
+      </p:sp>
+      <p:sp>
+        <p:nvSpPr>
+          <p:cNvPr id="17" name="Rounded Rectangle 11">
+            <a:extLst>
+              <a:ext uri="{FF2B5EF4-FFF2-40B4-BE49-F238E27FC236}">
+                <a16:creationId xmlns:a16="http://schemas.microsoft.com/office/drawing/2014/main" id="{24427E75-5CB8-2928-F568-D0C8EA634C25}"/>
+              </a:ext>
+            </a:extLst>
+          </p:cNvPr>
+          <p:cNvSpPr/>
+          <p:nvPr/>
+        </p:nvSpPr>
+        <p:spPr>
+          <a:xfrm>
+            <a:off x="8202240" y="1115640"/>
+            <a:ext cx="3254760" cy="381992"/>
+          </a:xfrm>
+          <a:prstGeom prst="roundRect">
+            <a:avLst>
+              <a:gd name="adj" fmla="val 16667"/>
+            </a:avLst>
+          </a:prstGeom>
+          <a:solidFill>
+            <a:srgbClr val="EF4444"/>
+          </a:solidFill>
+          <a:ln>
+            <a:solidFill>
+              <a:srgbClr val="EF4444"/>
+            </a:solidFill>
+            <a:round/>
+          </a:ln>
+          <a:effectLst>
+            <a:outerShdw blurRad="39960" dist="23040" dir="5400000" rotWithShape="0">
+              <a:srgbClr val="000000">
+                <a:alpha val="35000"/>
+              </a:srgbClr>
+            </a:outerShdw>
+          </a:effectLst>
+        </p:spPr>
+        <p:style>
+          <a:lnRef idx="1">
+            <a:schemeClr val="accent1"/>
+          </a:lnRef>
+          <a:fillRef idx="3">
+            <a:schemeClr val="accent1"/>
+          </a:fillRef>
+          <a:effectRef idx="2">
+            <a:schemeClr val="accent1"/>
+          </a:effectRef>
+          <a:fontRef idx="minor"/>
+        </p:style>
+        <p:txBody>
+          <a:bodyPr lIns="90000" tIns="45000" rIns="90000" bIns="45000" anchor="ctr">
+            <a:noAutofit/>
+          </a:bodyPr>
+          <a:lstStyle/>
+          <a:p>
+            <a:pPr defTabSz="457200">
+              <a:lnSpc>
+                <a:spcPct val="100000"/>
+              </a:lnSpc>
+            </a:pPr>
+            <a:endParaRPr lang="en-US" sz="1600" b="0" u="none" strike="noStrike">
+              <a:solidFill>
+                <a:schemeClr val="lt1"/>
+              </a:solidFill>
+              <a:effectLst/>
+              <a:uFillTx/>
+            </a:endParaRPr>
+          </a:p>
+        </p:txBody>
+      </p:sp>
+      <p:sp>
+        <p:nvSpPr>
+          <p:cNvPr id="19" name="TextBox 12">
+            <a:extLst>
+              <a:ext uri="{FF2B5EF4-FFF2-40B4-BE49-F238E27FC236}">
+                <a16:creationId xmlns:a16="http://schemas.microsoft.com/office/drawing/2014/main" id="{5474D8CC-250C-A6DE-78A2-E70B185CC409}"/>
+              </a:ext>
+            </a:extLst>
+          </p:cNvPr>
+          <p:cNvSpPr/>
+          <p:nvPr/>
+        </p:nvSpPr>
+        <p:spPr>
+          <a:xfrm>
+            <a:off x="8256960" y="1088805"/>
+            <a:ext cx="3145320" cy="400352"/>
+          </a:xfrm>
+          <a:prstGeom prst="rect">
+            <a:avLst/>
+          </a:prstGeom>
+          <a:noFill/>
+          <a:ln w="0">
+            <a:noFill/>
+          </a:ln>
+        </p:spPr>
+        <p:style>
+          <a:lnRef idx="0">
+            <a:scrgbClr r="0" g="0" b="0"/>
+          </a:lnRef>
+          <a:fillRef idx="0">
+            <a:scrgbClr r="0" g="0" b="0"/>
+          </a:fillRef>
+          <a:effectRef idx="0">
+            <a:scrgbClr r="0" g="0" b="0"/>
+          </a:effectRef>
+          <a:fontRef idx="minor"/>
+        </p:style>
+        <p:txBody>
+          <a:bodyPr lIns="76320" tIns="76320" rIns="76320" bIns="76320" anchor="ctr">
+            <a:spAutoFit/>
+          </a:bodyPr>
+          <a:lstStyle/>
+          <a:p>
+            <a:pPr defTabSz="457200">
+              <a:lnSpc>
+                <a:spcPct val="100000"/>
+              </a:lnSpc>
+            </a:pPr>
+            <a:r>
+              <a:rPr lang="en-US" sz="1600" b="1" u="none" strike="noStrike" dirty="0">
+                <a:solidFill>
+                  <a:srgbClr val="FFFFFF"/>
+                </a:solidFill>
+                <a:effectLst/>
+                <a:uFillTx/>
+              </a:rPr>
+              <a:t>Evita</a:t>
+            </a:r>
+            <a:endParaRPr lang="en-US" sz="1600" b="0" u="none" strike="noStrike" dirty="0">
+              <a:solidFill>
+                <a:srgbClr val="000000"/>
+              </a:solidFill>
+              <a:effectLst/>
+              <a:uFillTx/>
+            </a:endParaRPr>
+          </a:p>
+        </p:txBody>
+      </p:sp>
+    </p:spTree>
+    <p:extLst>
+      <p:ext uri="{BB962C8B-B14F-4D97-AF65-F5344CB8AC3E}">
+        <p14:creationId xmlns:p14="http://schemas.microsoft.com/office/powerpoint/2010/main" val="55025230"/>
+      </p:ext>
+    </p:extLst>
+  </p:cSld>
+  <p:clrMapOvr>
+    <a:masterClrMapping/>
+  </p:clrMapOvr>
+</p:sld>
+</file>
+
+<file path=ppt/slides/slide15.xml><?xml version="1.0" encoding="utf-8"?>
 <p:sld xmlns:a="http://schemas.openxmlformats.org/drawingml/2006/main" xmlns:r="http://schemas.openxmlformats.org/officeDocument/2006/relationships" xmlns:p="http://schemas.openxmlformats.org/presentationml/2006/main">
   <p:cSld>
     <p:bg>
@@ -13662,13 +16172,12 @@
                 <a:spcPct val="100000"/>
               </a:lnSpc>
             </a:pPr>
-            <a:endParaRPr lang="en-US" sz="1800" b="0" u="none" strike="noStrike">
+            <a:endParaRPr lang="en-US" sz="1400" b="0" u="none" strike="noStrike">
               <a:solidFill>
                 <a:schemeClr val="lt1"/>
               </a:solidFill>
               <a:effectLst/>
               <a:uFillTx/>
-              <a:latin typeface="Calibri"/>
             </a:endParaRPr>
           </a:p>
         </p:txBody>
@@ -13733,13 +16242,12 @@
                 <a:spcPct val="100000"/>
               </a:lnSpc>
             </a:pPr>
-            <a:endParaRPr lang="en-US" sz="1800" b="0" u="none" strike="noStrike">
+            <a:endParaRPr lang="en-US" sz="1400" b="0" u="none" strike="noStrike">
               <a:solidFill>
                 <a:schemeClr val="lt1"/>
               </a:solidFill>
               <a:effectLst/>
               <a:uFillTx/>
-              <a:latin typeface="Calibri"/>
             </a:endParaRPr>
           </a:p>
         </p:txBody>
@@ -13758,8 +16266,8 @@
         </p:nvSpPr>
         <p:spPr>
           <a:xfrm>
-            <a:off x="1735560" y="1220760"/>
-            <a:ext cx="219240" cy="164160"/>
+            <a:off x="1735560" y="1141136"/>
+            <a:ext cx="219240" cy="323408"/>
           </a:xfrm>
           <a:prstGeom prst="rect">
             <a:avLst/>
@@ -13793,23 +16301,21 @@
               </a:lnSpc>
             </a:pPr>
             <a:r>
-              <a:rPr lang="en-US" sz="1000" b="1" u="none" strike="noStrike">
+              <a:rPr lang="en-US" sz="1100" b="1" u="none" strike="noStrike" dirty="0">
                 <a:solidFill>
                   <a:srgbClr val="FFFFFF"/>
                 </a:solidFill>
                 <a:effectLst/>
                 <a:uFillTx/>
-                <a:latin typeface="Aptos"/>
               </a:rPr>
               <a:t>1</a:t>
             </a:r>
-            <a:endParaRPr lang="en-US" sz="1000" b="0" u="none" strike="noStrike">
+            <a:endParaRPr lang="en-US" sz="1100" b="0" u="none" strike="noStrike" dirty="0">
               <a:solidFill>
                 <a:srgbClr val="000000"/>
               </a:solidFill>
               <a:effectLst/>
               <a:uFillTx/>
-              <a:latin typeface="Arial"/>
             </a:endParaRPr>
           </a:p>
         </p:txBody>
@@ -13828,8 +16334,8 @@
         </p:nvSpPr>
         <p:spPr>
           <a:xfrm>
-            <a:off x="841320" y="1435680"/>
-            <a:ext cx="2007720" cy="621360"/>
+            <a:off x="841320" y="1453852"/>
+            <a:ext cx="2007720" cy="585018"/>
           </a:xfrm>
           <a:prstGeom prst="rect">
             <a:avLst/>
@@ -13857,50 +16363,51 @@
           </a:bodyPr>
           <a:lstStyle/>
           <a:p>
-            <a:r>
-              <a:rPr lang="en-US" sz="1100" b="1" u="none" strike="noStrike">
+            <a:pPr algn="ctr"/>
+            <a:r>
+              <a:rPr lang="en-US" sz="1400" b="1" u="none" strike="noStrike" dirty="0">
                 <a:solidFill>
                   <a:srgbClr val="1C3565"/>
                 </a:solidFill>
                 <a:effectLst/>
                 <a:uFillTx/>
-                <a:latin typeface="Aptos"/>
               </a:rPr>
               <a:t>Crear repo</a:t>
             </a:r>
-            <a:endParaRPr lang="en-US" sz="1100" b="0" u="none" strike="noStrike">
+            <a:r>
+              <a:rPr lang="en-US" sz="1400" dirty="0">
+                <a:solidFill>
+                  <a:srgbClr val="000000"/>
+                </a:solidFill>
+              </a:rPr>
+              <a:t> </a:t>
+            </a:r>
+            <a:r>
+              <a:rPr lang="en-US" sz="1400" b="1" u="none" strike="noStrike" dirty="0">
+                <a:solidFill>
+                  <a:srgbClr val="1C3565"/>
+                </a:solidFill>
+                <a:effectLst/>
+                <a:uFillTx/>
+              </a:rPr>
+              <a:t>y </a:t>
+            </a:r>
+            <a:r>
+              <a:rPr lang="en-US" sz="1400" b="1" u="none" strike="noStrike" dirty="0" err="1">
+                <a:solidFill>
+                  <a:srgbClr val="1C3565"/>
+                </a:solidFill>
+                <a:effectLst/>
+                <a:uFillTx/>
+              </a:rPr>
+              <a:t>estructura</a:t>
+            </a:r>
+            <a:endParaRPr lang="en-US" sz="1400" b="0" u="none" strike="noStrike" dirty="0">
               <a:solidFill>
                 <a:srgbClr val="000000"/>
               </a:solidFill>
               <a:effectLst/>
               <a:uFillTx/>
-              <a:latin typeface="Arial"/>
-            </a:endParaRPr>
-          </a:p>
-          <a:p>
-            <a:pPr algn="ctr" defTabSz="457200">
-              <a:lnSpc>
-                <a:spcPct val="100000"/>
-              </a:lnSpc>
-            </a:pPr>
-            <a:r>
-              <a:rPr lang="en-US" sz="1100" b="1" u="none" strike="noStrike">
-                <a:solidFill>
-                  <a:srgbClr val="1C3565"/>
-                </a:solidFill>
-                <a:effectLst/>
-                <a:uFillTx/>
-                <a:latin typeface="Aptos"/>
-              </a:rPr>
-              <a:t>y estructura</a:t>
-            </a:r>
-            <a:endParaRPr lang="en-US" sz="1100" b="0" u="none" strike="noStrike">
-              <a:solidFill>
-                <a:srgbClr val="000000"/>
-              </a:solidFill>
-              <a:effectLst/>
-              <a:uFillTx/>
-              <a:latin typeface="Arial"/>
             </a:endParaRPr>
           </a:p>
         </p:txBody>
@@ -13914,7 +16421,9 @@
               </a:ext>
             </a:extLst>
           </p:cNvPr>
-          <p:cNvCxnSpPr/>
+          <p:cNvCxnSpPr>
+            <a:cxnSpLocks/>
+          </p:cNvCxnSpPr>
           <p:nvPr/>
         </p:nvCxnSpPr>
         <p:spPr>
@@ -13995,13 +16504,12 @@
                 <a:spcPct val="100000"/>
               </a:lnSpc>
             </a:pPr>
-            <a:endParaRPr lang="en-US" sz="1800" b="0" u="none" strike="noStrike">
+            <a:endParaRPr lang="en-US" sz="1400" b="0" u="none" strike="noStrike">
               <a:solidFill>
                 <a:schemeClr val="lt1"/>
               </a:solidFill>
               <a:effectLst/>
               <a:uFillTx/>
-              <a:latin typeface="Calibri"/>
             </a:endParaRPr>
           </a:p>
         </p:txBody>
@@ -14066,13 +16574,12 @@
                 <a:spcPct val="100000"/>
               </a:lnSpc>
             </a:pPr>
-            <a:endParaRPr lang="en-US" sz="1800" b="0" u="none" strike="noStrike">
+            <a:endParaRPr lang="en-US" sz="1400" b="0" u="none" strike="noStrike">
               <a:solidFill>
                 <a:schemeClr val="lt1"/>
               </a:solidFill>
               <a:effectLst/>
               <a:uFillTx/>
-              <a:latin typeface="Calibri"/>
             </a:endParaRPr>
           </a:p>
         </p:txBody>
@@ -14091,8 +16598,8 @@
         </p:nvSpPr>
         <p:spPr>
           <a:xfrm>
-            <a:off x="3853440" y="1220760"/>
-            <a:ext cx="219240" cy="164160"/>
+            <a:off x="3853440" y="1141136"/>
+            <a:ext cx="219240" cy="323408"/>
           </a:xfrm>
           <a:prstGeom prst="rect">
             <a:avLst/>
@@ -14126,23 +16633,21 @@
               </a:lnSpc>
             </a:pPr>
             <a:r>
-              <a:rPr lang="en-US" sz="1000" b="1" u="none" strike="noStrike">
+              <a:rPr lang="en-US" sz="1100" b="1" u="none" strike="noStrike">
                 <a:solidFill>
                   <a:srgbClr val="FFFFFF"/>
                 </a:solidFill>
                 <a:effectLst/>
                 <a:uFillTx/>
-                <a:latin typeface="Aptos"/>
               </a:rPr>
               <a:t>2</a:t>
             </a:r>
-            <a:endParaRPr lang="en-US" sz="1000" b="0" u="none" strike="noStrike">
+            <a:endParaRPr lang="en-US" sz="1100" b="0" u="none" strike="noStrike">
               <a:solidFill>
                 <a:srgbClr val="000000"/>
               </a:solidFill>
               <a:effectLst/>
               <a:uFillTx/>
-              <a:latin typeface="Arial"/>
             </a:endParaRPr>
           </a:p>
         </p:txBody>
@@ -14161,8 +16666,8 @@
         </p:nvSpPr>
         <p:spPr>
           <a:xfrm>
-            <a:off x="2958840" y="1435680"/>
-            <a:ext cx="2007720" cy="621360"/>
+            <a:off x="2958840" y="1561574"/>
+            <a:ext cx="2007720" cy="369574"/>
           </a:xfrm>
           <a:prstGeom prst="rect">
             <a:avLst/>
@@ -14190,50 +16695,51 @@
           </a:bodyPr>
           <a:lstStyle/>
           <a:p>
-            <a:r>
-              <a:rPr lang="en-US" sz="1100" b="1" u="none" strike="noStrike">
+            <a:pPr algn="ctr"/>
+            <a:r>
+              <a:rPr lang="en-US" sz="1400" b="1" u="none" strike="noStrike" dirty="0" err="1">
                 <a:solidFill>
                   <a:srgbClr val="1C3565"/>
                 </a:solidFill>
                 <a:effectLst/>
                 <a:uFillTx/>
-                <a:latin typeface="Aptos"/>
               </a:rPr>
               <a:t>Configurar</a:t>
             </a:r>
-            <a:endParaRPr lang="en-US" sz="1100" b="0" u="none" strike="noStrike">
+            <a:r>
+              <a:rPr lang="en-US" sz="1400" dirty="0">
+                <a:solidFill>
+                  <a:srgbClr val="000000"/>
+                </a:solidFill>
+              </a:rPr>
+              <a:t> </a:t>
+            </a:r>
+            <a:r>
+              <a:rPr lang="en-US" sz="1400" b="1" u="none" strike="noStrike" dirty="0">
+                <a:solidFill>
+                  <a:srgbClr val="1C3565"/>
+                </a:solidFill>
+                <a:effectLst/>
+                <a:uFillTx/>
+              </a:rPr>
+              <a:t>.</a:t>
+            </a:r>
+            <a:r>
+              <a:rPr lang="en-US" sz="1400" b="1" u="none" strike="noStrike" dirty="0" err="1">
+                <a:solidFill>
+                  <a:srgbClr val="1C3565"/>
+                </a:solidFill>
+                <a:effectLst/>
+                <a:uFillTx/>
+              </a:rPr>
+              <a:t>gitignore</a:t>
+            </a:r>
+            <a:endParaRPr lang="en-US" sz="1400" b="0" u="none" strike="noStrike" dirty="0">
               <a:solidFill>
                 <a:srgbClr val="000000"/>
               </a:solidFill>
               <a:effectLst/>
               <a:uFillTx/>
-              <a:latin typeface="Arial"/>
-            </a:endParaRPr>
-          </a:p>
-          <a:p>
-            <a:pPr algn="ctr" defTabSz="457200">
-              <a:lnSpc>
-                <a:spcPct val="100000"/>
-              </a:lnSpc>
-            </a:pPr>
-            <a:r>
-              <a:rPr lang="en-US" sz="1100" b="1" u="none" strike="noStrike">
-                <a:solidFill>
-                  <a:srgbClr val="1C3565"/>
-                </a:solidFill>
-                <a:effectLst/>
-                <a:uFillTx/>
-                <a:latin typeface="Aptos"/>
-              </a:rPr>
-              <a:t>.gitignore</a:t>
-            </a:r>
-            <a:endParaRPr lang="en-US" sz="1100" b="0" u="none" strike="noStrike">
-              <a:solidFill>
-                <a:srgbClr val="000000"/>
-              </a:solidFill>
-              <a:effectLst/>
-              <a:uFillTx/>
-              <a:latin typeface="Arial"/>
             </a:endParaRPr>
           </a:p>
         </p:txBody>
@@ -14247,7 +16753,9 @@
               </a:ext>
             </a:extLst>
           </p:cNvPr>
-          <p:cNvCxnSpPr/>
+          <p:cNvCxnSpPr>
+            <a:cxnSpLocks/>
+          </p:cNvCxnSpPr>
           <p:nvPr/>
         </p:nvCxnSpPr>
         <p:spPr>
@@ -14328,13 +16836,12 @@
                 <a:spcPct val="100000"/>
               </a:lnSpc>
             </a:pPr>
-            <a:endParaRPr lang="en-US" sz="1800" b="0" u="none" strike="noStrike">
+            <a:endParaRPr lang="en-US" sz="1400" b="0" u="none" strike="noStrike">
               <a:solidFill>
                 <a:schemeClr val="lt1"/>
               </a:solidFill>
               <a:effectLst/>
               <a:uFillTx/>
-              <a:latin typeface="Calibri"/>
             </a:endParaRPr>
           </a:p>
         </p:txBody>
@@ -14399,13 +16906,12 @@
                 <a:spcPct val="100000"/>
               </a:lnSpc>
             </a:pPr>
-            <a:endParaRPr lang="en-US" sz="1800" b="0" u="none" strike="noStrike">
+            <a:endParaRPr lang="en-US" sz="1400" b="0" u="none" strike="noStrike">
               <a:solidFill>
                 <a:schemeClr val="lt1"/>
               </a:solidFill>
               <a:effectLst/>
               <a:uFillTx/>
-              <a:latin typeface="Calibri"/>
             </a:endParaRPr>
           </a:p>
         </p:txBody>
@@ -14424,8 +16930,8 @@
         </p:nvSpPr>
         <p:spPr>
           <a:xfrm>
-            <a:off x="5970960" y="1220760"/>
-            <a:ext cx="219240" cy="164160"/>
+            <a:off x="5970960" y="1141136"/>
+            <a:ext cx="219240" cy="323408"/>
           </a:xfrm>
           <a:prstGeom prst="rect">
             <a:avLst/>
@@ -14459,23 +16965,21 @@
               </a:lnSpc>
             </a:pPr>
             <a:r>
-              <a:rPr lang="en-US" sz="1000" b="1" u="none" strike="noStrike">
+              <a:rPr lang="en-US" sz="1100" b="1" u="none" strike="noStrike">
                 <a:solidFill>
                   <a:srgbClr val="FFFFFF"/>
                 </a:solidFill>
                 <a:effectLst/>
                 <a:uFillTx/>
-                <a:latin typeface="Aptos"/>
               </a:rPr>
               <a:t>3</a:t>
             </a:r>
-            <a:endParaRPr lang="en-US" sz="1000" b="0" u="none" strike="noStrike">
+            <a:endParaRPr lang="en-US" sz="1100" b="0" u="none" strike="noStrike">
               <a:solidFill>
                 <a:srgbClr val="000000"/>
               </a:solidFill>
               <a:effectLst/>
               <a:uFillTx/>
-              <a:latin typeface="Arial"/>
             </a:endParaRPr>
           </a:p>
         </p:txBody>
@@ -14494,8 +16998,8 @@
         </p:nvSpPr>
         <p:spPr>
           <a:xfrm>
-            <a:off x="5076720" y="1435680"/>
-            <a:ext cx="2007720" cy="621360"/>
+            <a:off x="5076720" y="1561574"/>
+            <a:ext cx="2007720" cy="369574"/>
           </a:xfrm>
           <a:prstGeom prst="rect">
             <a:avLst/>
@@ -14523,50 +17027,51 @@
           </a:bodyPr>
           <a:lstStyle/>
           <a:p>
-            <a:r>
-              <a:rPr lang="en-US" sz="1100" b="1" u="none" strike="noStrike">
+            <a:pPr algn="ctr"/>
+            <a:r>
+              <a:rPr lang="en-US" sz="1400" b="1" u="none" strike="noStrike" dirty="0" err="1">
                 <a:solidFill>
                   <a:srgbClr val="1C3565"/>
                 </a:solidFill>
                 <a:effectLst/>
                 <a:uFillTx/>
-                <a:latin typeface="Aptos"/>
               </a:rPr>
               <a:t>Publicar</a:t>
             </a:r>
-            <a:endParaRPr lang="en-US" sz="1100" b="0" u="none" strike="noStrike">
+            <a:r>
+              <a:rPr lang="en-US" sz="1400" dirty="0">
+                <a:solidFill>
+                  <a:srgbClr val="000000"/>
+                </a:solidFill>
+              </a:rPr>
+              <a:t> </a:t>
+            </a:r>
+            <a:r>
+              <a:rPr lang="en-US" sz="1400" b="1" u="none" strike="noStrike" dirty="0" err="1">
+                <a:solidFill>
+                  <a:srgbClr val="1C3565"/>
+                </a:solidFill>
+                <a:effectLst/>
+                <a:uFillTx/>
+              </a:rPr>
+              <a:t>en</a:t>
+            </a:r>
+            <a:r>
+              <a:rPr lang="en-US" sz="1400" b="1" u="none" strike="noStrike" dirty="0">
+                <a:solidFill>
+                  <a:srgbClr val="1C3565"/>
+                </a:solidFill>
+                <a:effectLst/>
+                <a:uFillTx/>
+              </a:rPr>
+              <a:t> GitHub</a:t>
+            </a:r>
+            <a:endParaRPr lang="en-US" sz="1400" b="0" u="none" strike="noStrike" dirty="0">
               <a:solidFill>
                 <a:srgbClr val="000000"/>
               </a:solidFill>
               <a:effectLst/>
               <a:uFillTx/>
-              <a:latin typeface="Arial"/>
-            </a:endParaRPr>
-          </a:p>
-          <a:p>
-            <a:pPr algn="ctr" defTabSz="457200">
-              <a:lnSpc>
-                <a:spcPct val="100000"/>
-              </a:lnSpc>
-            </a:pPr>
-            <a:r>
-              <a:rPr lang="en-US" sz="1100" b="1" u="none" strike="noStrike">
-                <a:solidFill>
-                  <a:srgbClr val="1C3565"/>
-                </a:solidFill>
-                <a:effectLst/>
-                <a:uFillTx/>
-                <a:latin typeface="Aptos"/>
-              </a:rPr>
-              <a:t>en GitHub</a:t>
-            </a:r>
-            <a:endParaRPr lang="en-US" sz="1100" b="0" u="none" strike="noStrike">
-              <a:solidFill>
-                <a:srgbClr val="000000"/>
-              </a:solidFill>
-              <a:effectLst/>
-              <a:uFillTx/>
-              <a:latin typeface="Arial"/>
             </a:endParaRPr>
           </a:p>
         </p:txBody>
@@ -14580,7 +17085,9 @@
               </a:ext>
             </a:extLst>
           </p:cNvPr>
-          <p:cNvCxnSpPr/>
+          <p:cNvCxnSpPr>
+            <a:cxnSpLocks/>
+          </p:cNvCxnSpPr>
           <p:nvPr/>
         </p:nvCxnSpPr>
         <p:spPr>
@@ -14661,13 +17168,12 @@
                 <a:spcPct val="100000"/>
               </a:lnSpc>
             </a:pPr>
-            <a:endParaRPr lang="en-US" sz="1800" b="0" u="none" strike="noStrike">
+            <a:endParaRPr lang="en-US" sz="1400" b="0" u="none" strike="noStrike">
               <a:solidFill>
                 <a:schemeClr val="lt1"/>
               </a:solidFill>
               <a:effectLst/>
               <a:uFillTx/>
-              <a:latin typeface="Calibri"/>
             </a:endParaRPr>
           </a:p>
         </p:txBody>
@@ -14732,13 +17238,12 @@
                 <a:spcPct val="100000"/>
               </a:lnSpc>
             </a:pPr>
-            <a:endParaRPr lang="en-US" sz="1800" b="0" u="none" strike="noStrike">
+            <a:endParaRPr lang="en-US" sz="1400" b="0" u="none" strike="noStrike">
               <a:solidFill>
                 <a:schemeClr val="lt1"/>
               </a:solidFill>
               <a:effectLst/>
               <a:uFillTx/>
-              <a:latin typeface="Calibri"/>
             </a:endParaRPr>
           </a:p>
         </p:txBody>
@@ -14757,8 +17262,8 @@
         </p:nvSpPr>
         <p:spPr>
           <a:xfrm>
-            <a:off x="8088840" y="1220760"/>
-            <a:ext cx="219240" cy="164160"/>
+            <a:off x="8088840" y="1141136"/>
+            <a:ext cx="219240" cy="323408"/>
           </a:xfrm>
           <a:prstGeom prst="rect">
             <a:avLst/>
@@ -14792,23 +17297,21 @@
               </a:lnSpc>
             </a:pPr>
             <a:r>
-              <a:rPr lang="en-US" sz="1000" b="1" u="none" strike="noStrike">
+              <a:rPr lang="en-US" sz="1100" b="1" u="none" strike="noStrike">
                 <a:solidFill>
                   <a:srgbClr val="FFFFFF"/>
                 </a:solidFill>
                 <a:effectLst/>
                 <a:uFillTx/>
-                <a:latin typeface="Aptos"/>
               </a:rPr>
               <a:t>4</a:t>
             </a:r>
-            <a:endParaRPr lang="en-US" sz="1000" b="0" u="none" strike="noStrike">
+            <a:endParaRPr lang="en-US" sz="1100" b="0" u="none" strike="noStrike">
               <a:solidFill>
                 <a:srgbClr val="000000"/>
               </a:solidFill>
               <a:effectLst/>
               <a:uFillTx/>
-              <a:latin typeface="Arial"/>
             </a:endParaRPr>
           </a:p>
         </p:txBody>
@@ -14827,8 +17330,8 @@
         </p:nvSpPr>
         <p:spPr>
           <a:xfrm>
-            <a:off x="7194600" y="1435680"/>
-            <a:ext cx="2007720" cy="621360"/>
+            <a:off x="7194600" y="1453852"/>
+            <a:ext cx="2007720" cy="585018"/>
           </a:xfrm>
           <a:prstGeom prst="rect">
             <a:avLst/>
@@ -14856,50 +17359,73 @@
           </a:bodyPr>
           <a:lstStyle/>
           <a:p>
-            <a:r>
-              <a:rPr lang="en-US" sz="1100" b="1" u="none" strike="noStrike">
+            <a:pPr algn="ctr"/>
+            <a:r>
+              <a:rPr lang="en-US" sz="1400" b="1" u="none" strike="noStrike" dirty="0">
                 <a:solidFill>
                   <a:srgbClr val="1C3565"/>
                 </a:solidFill>
                 <a:effectLst/>
                 <a:uFillTx/>
-                <a:latin typeface="Aptos"/>
-              </a:rPr>
-              <a:t>Tres errores</a:t>
-            </a:r>
-            <a:endParaRPr lang="en-US" sz="1100" b="0" u="none" strike="noStrike">
+              </a:rPr>
+              <a:t>Tres </a:t>
+            </a:r>
+            <a:r>
+              <a:rPr lang="en-US" sz="1400" b="1" u="none" strike="noStrike" dirty="0" err="1">
+                <a:solidFill>
+                  <a:srgbClr val="1C3565"/>
+                </a:solidFill>
+                <a:effectLst/>
+                <a:uFillTx/>
+              </a:rPr>
+              <a:t>errores</a:t>
+            </a:r>
+            <a:r>
+              <a:rPr lang="en-US" sz="1400" b="1" u="none" strike="noStrike" dirty="0">
+                <a:solidFill>
+                  <a:srgbClr val="000000"/>
+                </a:solidFill>
+                <a:effectLst/>
+                <a:uFillTx/>
+              </a:rPr>
+              <a:t>, </a:t>
+            </a:r>
+            <a:r>
+              <a:rPr lang="en-US" sz="1400" b="1" u="none" strike="noStrike" dirty="0" err="1">
+                <a:solidFill>
+                  <a:srgbClr val="1C3565"/>
+                </a:solidFill>
+                <a:effectLst/>
+                <a:uFillTx/>
+              </a:rPr>
+              <a:t>tres</a:t>
+            </a:r>
+            <a:r>
+              <a:rPr lang="en-US" sz="1400" b="1" u="none" strike="noStrike" dirty="0">
+                <a:solidFill>
+                  <a:srgbClr val="1C3565"/>
+                </a:solidFill>
+                <a:effectLst/>
+                <a:uFillTx/>
+              </a:rPr>
+              <a:t> </a:t>
+            </a:r>
+            <a:r>
+              <a:rPr lang="en-US" sz="1400" b="1" u="none" strike="noStrike" dirty="0" err="1">
+                <a:solidFill>
+                  <a:srgbClr val="1C3565"/>
+                </a:solidFill>
+                <a:effectLst/>
+                <a:uFillTx/>
+              </a:rPr>
+              <a:t>decisiones</a:t>
+            </a:r>
+            <a:endParaRPr lang="en-US" sz="1400" b="0" u="none" strike="noStrike" dirty="0">
               <a:solidFill>
                 <a:srgbClr val="000000"/>
               </a:solidFill>
               <a:effectLst/>
               <a:uFillTx/>
-              <a:latin typeface="Arial"/>
-            </a:endParaRPr>
-          </a:p>
-          <a:p>
-            <a:pPr algn="ctr" defTabSz="457200">
-              <a:lnSpc>
-                <a:spcPct val="100000"/>
-              </a:lnSpc>
-            </a:pPr>
-            <a:r>
-              <a:rPr lang="en-US" sz="1100" b="1" u="none" strike="noStrike">
-                <a:solidFill>
-                  <a:srgbClr val="1C3565"/>
-                </a:solidFill>
-                <a:effectLst/>
-                <a:uFillTx/>
-                <a:latin typeface="Aptos"/>
-              </a:rPr>
-              <a:t>tres decisiones</a:t>
-            </a:r>
-            <a:endParaRPr lang="en-US" sz="1100" b="0" u="none" strike="noStrike">
-              <a:solidFill>
-                <a:srgbClr val="000000"/>
-              </a:solidFill>
-              <a:effectLst/>
-              <a:uFillTx/>
-              <a:latin typeface="Arial"/>
             </a:endParaRPr>
           </a:p>
         </p:txBody>
@@ -14913,7 +17439,9 @@
               </a:ext>
             </a:extLst>
           </p:cNvPr>
-          <p:cNvCxnSpPr/>
+          <p:cNvCxnSpPr>
+            <a:cxnSpLocks/>
+          </p:cNvCxnSpPr>
           <p:nvPr/>
         </p:nvCxnSpPr>
         <p:spPr>
@@ -14994,13 +17522,12 @@
                 <a:spcPct val="100000"/>
               </a:lnSpc>
             </a:pPr>
-            <a:endParaRPr lang="en-US" sz="1800" b="0" u="none" strike="noStrike">
+            <a:endParaRPr lang="en-US" sz="1400" b="0" u="none" strike="noStrike">
               <a:solidFill>
                 <a:schemeClr val="lt1"/>
               </a:solidFill>
               <a:effectLst/>
               <a:uFillTx/>
-              <a:latin typeface="Calibri"/>
             </a:endParaRPr>
           </a:p>
         </p:txBody>
@@ -15065,13 +17592,12 @@
                 <a:spcPct val="100000"/>
               </a:lnSpc>
             </a:pPr>
-            <a:endParaRPr lang="en-US" sz="1800" b="0" u="none" strike="noStrike">
+            <a:endParaRPr lang="en-US" sz="1400" b="0" u="none" strike="noStrike">
               <a:solidFill>
                 <a:schemeClr val="lt1"/>
               </a:solidFill>
               <a:effectLst/>
               <a:uFillTx/>
-              <a:latin typeface="Calibri"/>
             </a:endParaRPr>
           </a:p>
         </p:txBody>
@@ -15090,8 +17616,8 @@
         </p:nvSpPr>
         <p:spPr>
           <a:xfrm>
-            <a:off x="10206360" y="1220760"/>
-            <a:ext cx="219240" cy="164160"/>
+            <a:off x="10206360" y="1141136"/>
+            <a:ext cx="219240" cy="323408"/>
           </a:xfrm>
           <a:prstGeom prst="rect">
             <a:avLst/>
@@ -15125,23 +17651,21 @@
               </a:lnSpc>
             </a:pPr>
             <a:r>
-              <a:rPr lang="en-US" sz="1000" b="1" u="none" strike="noStrike">
+              <a:rPr lang="en-US" sz="1100" b="1" u="none" strike="noStrike">
                 <a:solidFill>
                   <a:srgbClr val="FFFFFF"/>
                 </a:solidFill>
                 <a:effectLst/>
                 <a:uFillTx/>
-                <a:latin typeface="Aptos"/>
               </a:rPr>
               <a:t>5</a:t>
             </a:r>
-            <a:endParaRPr lang="en-US" sz="1000" b="0" u="none" strike="noStrike">
+            <a:endParaRPr lang="en-US" sz="1100" b="0" u="none" strike="noStrike">
               <a:solidFill>
                 <a:srgbClr val="000000"/>
               </a:solidFill>
               <a:effectLst/>
               <a:uFillTx/>
-              <a:latin typeface="Arial"/>
             </a:endParaRPr>
           </a:p>
         </p:txBody>
@@ -15160,8 +17684,8 @@
         </p:nvSpPr>
         <p:spPr>
           <a:xfrm>
-            <a:off x="9312120" y="1435680"/>
-            <a:ext cx="2007720" cy="621360"/>
+            <a:off x="9312120" y="1453852"/>
+            <a:ext cx="2007720" cy="585018"/>
           </a:xfrm>
           <a:prstGeom prst="rect">
             <a:avLst/>
@@ -15189,50 +17713,61 @@
           </a:bodyPr>
           <a:lstStyle/>
           <a:p>
-            <a:r>
-              <a:rPr lang="en-US" sz="1100" b="1" u="none" strike="noStrike">
+            <a:pPr algn="ctr"/>
+            <a:r>
+              <a:rPr lang="en-US" sz="1400" b="1" u="none" strike="noStrike" dirty="0">
                 <a:solidFill>
                   <a:srgbClr val="1C3565"/>
                 </a:solidFill>
                 <a:effectLst/>
                 <a:uFillTx/>
-                <a:latin typeface="Aptos"/>
               </a:rPr>
               <a:t>PR + check</a:t>
             </a:r>
-            <a:endParaRPr lang="en-US" sz="1100" b="0" u="none" strike="noStrike">
+            <a:r>
+              <a:rPr lang="en-US" sz="1400" dirty="0">
+                <a:solidFill>
+                  <a:srgbClr val="000000"/>
+                </a:solidFill>
+              </a:rPr>
+              <a:t> </a:t>
+            </a:r>
+            <a:r>
+              <a:rPr lang="en-US" sz="1400" b="1" u="none" strike="noStrike" dirty="0">
+                <a:solidFill>
+                  <a:srgbClr val="1C3565"/>
+                </a:solidFill>
+                <a:effectLst/>
+                <a:uFillTx/>
+              </a:rPr>
+              <a:t>y </a:t>
+            </a:r>
+            <a:r>
+              <a:rPr lang="en-US" sz="1400" b="1" u="none" strike="noStrike" dirty="0" err="1">
+                <a:solidFill>
+                  <a:srgbClr val="1C3565"/>
+                </a:solidFill>
+                <a:effectLst/>
+                <a:uFillTx/>
+              </a:rPr>
+              <a:t>etiqueta</a:t>
+            </a:r>
+            <a:r>
+              <a:rPr lang="en-US" sz="1400" b="1" u="none" strike="noStrike" dirty="0">
+                <a:solidFill>
+                  <a:srgbClr val="1C3565"/>
+                </a:solidFill>
+                <a:effectLst/>
+                <a:uFillTx/>
+              </a:rPr>
+              <a:t> v0.1.0</a:t>
+            </a:r>
+            <a:endParaRPr lang="en-US" sz="1400" b="0" u="none" strike="noStrike" dirty="0">
               <a:solidFill>
                 <a:srgbClr val="000000"/>
               </a:solidFill>
               <a:effectLst/>
               <a:uFillTx/>
-              <a:latin typeface="Arial"/>
-            </a:endParaRPr>
-          </a:p>
-          <a:p>
-            <a:pPr algn="ctr" defTabSz="457200">
-              <a:lnSpc>
-                <a:spcPct val="100000"/>
-              </a:lnSpc>
-            </a:pPr>
-            <a:r>
-              <a:rPr lang="en-US" sz="1100" b="1" u="none" strike="noStrike">
-                <a:solidFill>
-                  <a:srgbClr val="1C3565"/>
-                </a:solidFill>
-                <a:effectLst/>
-                <a:uFillTx/>
-                <a:latin typeface="Aptos"/>
-              </a:rPr>
-              <a:t>y etiqueta v0.1.0</a:t>
-            </a:r>
-            <a:endParaRPr lang="en-US" sz="1100" b="0" u="none" strike="noStrike">
-              <a:solidFill>
-                <a:srgbClr val="000000"/>
-              </a:solidFill>
-              <a:effectLst/>
-              <a:uFillTx/>
-              <a:latin typeface="Arial"/>
             </a:endParaRPr>
           </a:p>
         </p:txBody>
@@ -15303,16 +17838,96 @@
               </a:spcAft>
             </a:pPr>
             <a:r>
-              <a:rPr lang="en-US" sz="1400" b="1" u="none" strike="noStrike">
+              <a:rPr lang="en-US" sz="1400" b="1" u="none" strike="noStrike" dirty="0">
                 <a:solidFill>
                   <a:srgbClr val="0A5C48"/>
                 </a:solidFill>
                 <a:effectLst/>
                 <a:uFillTx/>
               </a:rPr>
-              <a:t>Al salir de la sesión deberías poder…</a:t>
-            </a:r>
-            <a:endParaRPr lang="en-US" sz="1400" b="0" u="none" strike="noStrike">
+              <a:t>Al </a:t>
+            </a:r>
+            <a:r>
+              <a:rPr lang="en-US" sz="1400" b="1" u="none" strike="noStrike" dirty="0" err="1">
+                <a:solidFill>
+                  <a:srgbClr val="0A5C48"/>
+                </a:solidFill>
+                <a:effectLst/>
+                <a:uFillTx/>
+              </a:rPr>
+              <a:t>salir</a:t>
+            </a:r>
+            <a:r>
+              <a:rPr lang="en-US" sz="1400" b="1" u="none" strike="noStrike" dirty="0">
+                <a:solidFill>
+                  <a:srgbClr val="0A5C48"/>
+                </a:solidFill>
+                <a:effectLst/>
+                <a:uFillTx/>
+              </a:rPr>
+              <a:t> de la </a:t>
+            </a:r>
+            <a:r>
+              <a:rPr lang="en-US" sz="1400" b="1" u="none" strike="noStrike" dirty="0" err="1">
+                <a:solidFill>
+                  <a:srgbClr val="0A5C48"/>
+                </a:solidFill>
+                <a:effectLst/>
+                <a:uFillTx/>
+              </a:rPr>
+              <a:t>sesión</a:t>
+            </a:r>
+            <a:r>
+              <a:rPr lang="en-US" sz="1400" b="1" u="none" strike="noStrike" dirty="0">
+                <a:solidFill>
+                  <a:srgbClr val="0A5C48"/>
+                </a:solidFill>
+                <a:effectLst/>
+                <a:uFillTx/>
+              </a:rPr>
+              <a:t> </a:t>
+            </a:r>
+            <a:r>
+              <a:rPr lang="en-US" sz="1400" b="1" u="none" strike="noStrike" dirty="0" err="1">
+                <a:solidFill>
+                  <a:srgbClr val="0A5C48"/>
+                </a:solidFill>
+                <a:effectLst/>
+                <a:uFillTx/>
+              </a:rPr>
+              <a:t>deberías</a:t>
+            </a:r>
+            <a:r>
+              <a:rPr lang="en-US" sz="1400" b="1" u="none" strike="noStrike" dirty="0">
+                <a:solidFill>
+                  <a:srgbClr val="0A5C48"/>
+                </a:solidFill>
+                <a:effectLst/>
+                <a:uFillTx/>
+              </a:rPr>
+              <a:t> </a:t>
+            </a:r>
+            <a:r>
+              <a:rPr lang="en-US" sz="1400" b="1" u="none" strike="noStrike" dirty="0" err="1">
+                <a:solidFill>
+                  <a:srgbClr val="0A5C48"/>
+                </a:solidFill>
+                <a:effectLst/>
+                <a:uFillTx/>
+              </a:rPr>
+              <a:t>poder</a:t>
+            </a:r>
+            <a:r>
+              <a:rPr lang="en-US" sz="1400" b="1" u="none" strike="noStrike" dirty="0">
+                <a:solidFill>
+                  <a:srgbClr val="0A5C48"/>
+                </a:solidFill>
+                <a:effectLst/>
+                <a:uFillTx/>
+              </a:rPr>
+              <a:t>…</a:t>
+            </a:r>
+            <a:endParaRPr lang="en-US" sz="1400" b="0" u="none" strike="noStrike" dirty="0">
               <a:solidFill>
                 <a:srgbClr val="000000"/>
               </a:solidFill>
@@ -15321,25 +17936,137 @@
             </a:endParaRPr>
           </a:p>
           <a:p>
-            <a:pPr defTabSz="457200">
+            <a:pPr marL="285750" indent="-285750" defTabSz="457200">
               <a:lnSpc>
                 <a:spcPct val="100000"/>
               </a:lnSpc>
               <a:spcAft>
                 <a:spcPts val="600"/>
               </a:spcAft>
+              <a:buFont typeface="Arial" panose="020B0604020202020204" pitchFamily="34" charset="0"/>
+              <a:buChar char="•"/>
             </a:pPr>
             <a:r>
-              <a:rPr lang="en-US" sz="1400" b="0" u="none" strike="noStrike">
-                <a:solidFill>
-                  <a:srgbClr val="2D3436"/>
-                </a:solidFill>
-                <a:effectLst/>
-                <a:uFillTx/>
-              </a:rPr>
-              <a:t>Preparar el repositorio del curso como fuente de verdad.</a:t>
-            </a:r>
-            <a:endParaRPr lang="en-US" sz="1400" b="0" u="none" strike="noStrike">
+              <a:rPr lang="en-US" sz="1400" b="0" u="none" strike="noStrike" dirty="0" err="1">
+                <a:solidFill>
+                  <a:srgbClr val="2D3436"/>
+                </a:solidFill>
+                <a:effectLst/>
+                <a:uFillTx/>
+              </a:rPr>
+              <a:t>Preparar</a:t>
+            </a:r>
+            <a:r>
+              <a:rPr lang="en-US" sz="1400" b="0" u="none" strike="noStrike" dirty="0">
+                <a:solidFill>
+                  <a:srgbClr val="2D3436"/>
+                </a:solidFill>
+                <a:effectLst/>
+                <a:uFillTx/>
+              </a:rPr>
+              <a:t> el </a:t>
+            </a:r>
+            <a:r>
+              <a:rPr lang="en-US" sz="1400" b="0" u="none" strike="noStrike" dirty="0" err="1">
+                <a:solidFill>
+                  <a:srgbClr val="2D3436"/>
+                </a:solidFill>
+                <a:effectLst/>
+                <a:uFillTx/>
+              </a:rPr>
+              <a:t>repositorio</a:t>
+            </a:r>
+            <a:r>
+              <a:rPr lang="en-US" sz="1400" b="0" u="none" strike="noStrike" dirty="0">
+                <a:solidFill>
+                  <a:srgbClr val="2D3436"/>
+                </a:solidFill>
+                <a:effectLst/>
+                <a:uFillTx/>
+              </a:rPr>
+              <a:t> del </a:t>
+            </a:r>
+            <a:r>
+              <a:rPr lang="en-US" sz="1400" b="0" u="none" strike="noStrike" dirty="0" err="1">
+                <a:solidFill>
+                  <a:srgbClr val="2D3436"/>
+                </a:solidFill>
+                <a:effectLst/>
+                <a:uFillTx/>
+              </a:rPr>
+              <a:t>curso</a:t>
+            </a:r>
+            <a:r>
+              <a:rPr lang="en-US" sz="1400" b="0" u="none" strike="noStrike" dirty="0">
+                <a:solidFill>
+                  <a:srgbClr val="2D3436"/>
+                </a:solidFill>
+                <a:effectLst/>
+                <a:uFillTx/>
+              </a:rPr>
+              <a:t> </a:t>
+            </a:r>
+            <a:r>
+              <a:rPr lang="en-US" sz="1400" b="0" u="none" strike="noStrike" dirty="0" err="1">
+                <a:solidFill>
+                  <a:srgbClr val="2D3436"/>
+                </a:solidFill>
+                <a:effectLst/>
+                <a:uFillTx/>
+              </a:rPr>
+              <a:t>como</a:t>
+            </a:r>
+            <a:r>
+              <a:rPr lang="en-US" sz="1400" b="0" u="none" strike="noStrike" dirty="0">
+                <a:solidFill>
+                  <a:srgbClr val="2D3436"/>
+                </a:solidFill>
+                <a:effectLst/>
+                <a:uFillTx/>
+              </a:rPr>
+              <a:t> </a:t>
+            </a:r>
+            <a:r>
+              <a:rPr lang="en-US" sz="1400" b="0" u="none" strike="noStrike" dirty="0" err="1">
+                <a:solidFill>
+                  <a:srgbClr val="2D3436"/>
+                </a:solidFill>
+                <a:effectLst/>
+                <a:uFillTx/>
+              </a:rPr>
+              <a:t>fuente</a:t>
+            </a:r>
+            <a:r>
+              <a:rPr lang="en-US" sz="1400" b="0" u="none" strike="noStrike" dirty="0">
+                <a:solidFill>
+                  <a:srgbClr val="2D3436"/>
+                </a:solidFill>
+                <a:effectLst/>
+                <a:uFillTx/>
+              </a:rPr>
+              <a:t> de </a:t>
+            </a:r>
+            <a:r>
+              <a:rPr lang="en-US" sz="1400" b="0" u="none" strike="noStrike" dirty="0" err="1">
+                <a:solidFill>
+                  <a:srgbClr val="2D3436"/>
+                </a:solidFill>
+                <a:effectLst/>
+                <a:uFillTx/>
+              </a:rPr>
+              <a:t>verdad</a:t>
+            </a:r>
+            <a:r>
+              <a:rPr lang="en-US" sz="1400" b="0" u="none" strike="noStrike" dirty="0">
+                <a:solidFill>
+                  <a:srgbClr val="2D3436"/>
+                </a:solidFill>
+                <a:effectLst/>
+                <a:uFillTx/>
+              </a:rPr>
+              <a:t>.</a:t>
+            </a:r>
+            <a:endParaRPr lang="en-US" sz="1400" b="0" u="none" strike="noStrike" dirty="0">
               <a:solidFill>
                 <a:srgbClr val="000000"/>
               </a:solidFill>
@@ -15348,25 +18075,137 @@
             </a:endParaRPr>
           </a:p>
           <a:p>
-            <a:pPr defTabSz="457200">
+            <a:pPr marL="285750" indent="-285750" defTabSz="457200">
               <a:lnSpc>
                 <a:spcPct val="100000"/>
               </a:lnSpc>
               <a:spcAft>
                 <a:spcPts val="600"/>
               </a:spcAft>
+              <a:buFont typeface="Arial" panose="020B0604020202020204" pitchFamily="34" charset="0"/>
+              <a:buChar char="•"/>
             </a:pPr>
             <a:r>
-              <a:rPr lang="en-US" sz="1400" b="0" u="none" strike="noStrike">
-                <a:solidFill>
-                  <a:srgbClr val="2D3436"/>
-                </a:solidFill>
-                <a:effectLst/>
-                <a:uFillTx/>
-              </a:rPr>
-              <a:t>Proteger el histórico de estados que sí deben conservarse.</a:t>
-            </a:r>
-            <a:endParaRPr lang="en-US" sz="1400" b="0" u="none" strike="noStrike">
+              <a:rPr lang="en-US" sz="1400" b="0" u="none" strike="noStrike" dirty="0" err="1">
+                <a:solidFill>
+                  <a:srgbClr val="2D3436"/>
+                </a:solidFill>
+                <a:effectLst/>
+                <a:uFillTx/>
+              </a:rPr>
+              <a:t>Proteger</a:t>
+            </a:r>
+            <a:r>
+              <a:rPr lang="en-US" sz="1400" b="0" u="none" strike="noStrike" dirty="0">
+                <a:solidFill>
+                  <a:srgbClr val="2D3436"/>
+                </a:solidFill>
+                <a:effectLst/>
+                <a:uFillTx/>
+              </a:rPr>
+              <a:t> el histórico de </a:t>
+            </a:r>
+            <a:r>
+              <a:rPr lang="en-US" sz="1400" b="0" u="none" strike="noStrike" dirty="0" err="1">
+                <a:solidFill>
+                  <a:srgbClr val="2D3436"/>
+                </a:solidFill>
+                <a:effectLst/>
+                <a:uFillTx/>
+              </a:rPr>
+              <a:t>estados</a:t>
+            </a:r>
+            <a:r>
+              <a:rPr lang="en-US" sz="1400" b="0" u="none" strike="noStrike" dirty="0">
+                <a:solidFill>
+                  <a:srgbClr val="2D3436"/>
+                </a:solidFill>
+                <a:effectLst/>
+                <a:uFillTx/>
+              </a:rPr>
+              <a:t> </a:t>
+            </a:r>
+            <a:r>
+              <a:rPr lang="en-US" sz="1400" b="0" u="none" strike="noStrike" dirty="0" err="1">
+                <a:solidFill>
+                  <a:srgbClr val="2D3436"/>
+                </a:solidFill>
+                <a:effectLst/>
+                <a:uFillTx/>
+              </a:rPr>
+              <a:t>que</a:t>
+            </a:r>
+            <a:r>
+              <a:rPr lang="en-US" sz="1400" b="0" u="none" strike="noStrike" dirty="0">
+                <a:solidFill>
+                  <a:srgbClr val="2D3436"/>
+                </a:solidFill>
+                <a:effectLst/>
+                <a:uFillTx/>
+              </a:rPr>
+              <a:t> </a:t>
+            </a:r>
+            <a:r>
+              <a:rPr lang="en-US" sz="1400" b="0" u="none" strike="noStrike" dirty="0" err="1">
+                <a:solidFill>
+                  <a:srgbClr val="2D3436"/>
+                </a:solidFill>
+                <a:effectLst/>
+                <a:uFillTx/>
+              </a:rPr>
+              <a:t>sí</a:t>
+            </a:r>
+            <a:r>
+              <a:rPr lang="en-US" sz="1400" b="0" u="none" strike="noStrike" dirty="0">
+                <a:solidFill>
+                  <a:srgbClr val="2D3436"/>
+                </a:solidFill>
+                <a:effectLst/>
+                <a:uFillTx/>
+              </a:rPr>
+              <a:t> </a:t>
+            </a:r>
+            <a:r>
+              <a:rPr lang="en-US" sz="1400" b="0" u="none" strike="noStrike" dirty="0" err="1">
+                <a:solidFill>
+                  <a:srgbClr val="2D3436"/>
+                </a:solidFill>
+                <a:effectLst/>
+                <a:uFillTx/>
+              </a:rPr>
+              <a:t>deben</a:t>
+            </a:r>
+            <a:r>
+              <a:rPr lang="en-US" sz="1400" b="0" u="none" strike="noStrike" dirty="0">
+                <a:solidFill>
+                  <a:srgbClr val="2D3436"/>
+                </a:solidFill>
+                <a:effectLst/>
+                <a:uFillTx/>
+              </a:rPr>
+              <a:t> </a:t>
+            </a:r>
+            <a:r>
+              <a:rPr lang="en-US" sz="1400" b="0" u="none" strike="noStrike" dirty="0" err="1">
+                <a:solidFill>
+                  <a:srgbClr val="2D3436"/>
+                </a:solidFill>
+                <a:effectLst/>
+                <a:uFillTx/>
+              </a:rPr>
+              <a:t>conservarse</a:t>
+            </a:r>
+            <a:r>
+              <a:rPr lang="en-US" sz="1400" b="0" u="none" strike="noStrike" dirty="0">
+                <a:solidFill>
+                  <a:srgbClr val="2D3436"/>
+                </a:solidFill>
+                <a:effectLst/>
+                <a:uFillTx/>
+              </a:rPr>
+              <a:t>.</a:t>
+            </a:r>
+            <a:endParaRPr lang="en-US" sz="1400" b="0" u="none" strike="noStrike" dirty="0">
               <a:solidFill>
                 <a:srgbClr val="000000"/>
               </a:solidFill>
@@ -15375,25 +18214,147 @@
             </a:endParaRPr>
           </a:p>
           <a:p>
-            <a:pPr defTabSz="457200">
+            <a:pPr marL="285750" indent="-285750" defTabSz="457200">
               <a:lnSpc>
                 <a:spcPct val="100000"/>
               </a:lnSpc>
               <a:spcAft>
                 <a:spcPts val="600"/>
               </a:spcAft>
+              <a:buFont typeface="Arial" panose="020B0604020202020204" pitchFamily="34" charset="0"/>
+              <a:buChar char="•"/>
             </a:pPr>
             <a:r>
-              <a:rPr lang="en-US" sz="1400" b="0" u="none" strike="noStrike">
-                <a:solidFill>
-                  <a:srgbClr val="2D3436"/>
-                </a:solidFill>
-                <a:effectLst/>
-                <a:uFillTx/>
-              </a:rPr>
-              <a:t>Crear una rama, una PR, checks y una primera etiqueta.</a:t>
-            </a:r>
-            <a:endParaRPr lang="en-US" sz="1400" b="0" u="none" strike="noStrike">
+              <a:rPr lang="en-US" sz="1400" b="0" u="none" strike="noStrike" dirty="0">
+                <a:solidFill>
+                  <a:srgbClr val="2D3436"/>
+                </a:solidFill>
+                <a:effectLst/>
+                <a:uFillTx/>
+              </a:rPr>
+              <a:t>Crear </a:t>
+            </a:r>
+            <a:r>
+              <a:rPr lang="en-US" sz="1400" b="0" u="none" strike="noStrike" dirty="0" err="1">
+                <a:solidFill>
+                  <a:srgbClr val="2D3436"/>
+                </a:solidFill>
+                <a:effectLst/>
+                <a:uFillTx/>
+              </a:rPr>
+              <a:t>una</a:t>
+            </a:r>
+            <a:r>
+              <a:rPr lang="en-US" sz="1400" b="0" u="none" strike="noStrike" dirty="0">
+                <a:solidFill>
+                  <a:srgbClr val="2D3436"/>
+                </a:solidFill>
+                <a:effectLst/>
+                <a:uFillTx/>
+              </a:rPr>
+              <a:t> </a:t>
+            </a:r>
+            <a:r>
+              <a:rPr lang="en-US" sz="1400" b="0" u="none" strike="noStrike" dirty="0" err="1">
+                <a:solidFill>
+                  <a:srgbClr val="2D3436"/>
+                </a:solidFill>
+                <a:effectLst/>
+                <a:uFillTx/>
+              </a:rPr>
+              <a:t>rama</a:t>
+            </a:r>
+            <a:r>
+              <a:rPr lang="en-US" sz="1400" b="0" u="none" strike="noStrike" dirty="0">
+                <a:solidFill>
+                  <a:srgbClr val="2D3436"/>
+                </a:solidFill>
+                <a:effectLst/>
+                <a:uFillTx/>
+              </a:rPr>
+              <a:t>, </a:t>
+            </a:r>
+            <a:r>
+              <a:rPr lang="en-US" sz="1400" b="0" u="none" strike="noStrike" dirty="0" err="1">
+                <a:solidFill>
+                  <a:srgbClr val="2D3436"/>
+                </a:solidFill>
+                <a:effectLst/>
+                <a:uFillTx/>
+              </a:rPr>
+              <a:t>una</a:t>
+            </a:r>
+            <a:r>
+              <a:rPr lang="en-US" sz="1400" b="0" u="none" strike="noStrike" dirty="0">
+                <a:solidFill>
+                  <a:srgbClr val="2D3436"/>
+                </a:solidFill>
+                <a:effectLst/>
+                <a:uFillTx/>
+              </a:rPr>
+              <a:t> PR, checks y </a:t>
+            </a:r>
+            <a:r>
+              <a:rPr lang="en-US" sz="1400" b="0" u="none" strike="noStrike" dirty="0" err="1">
+                <a:solidFill>
+                  <a:srgbClr val="2D3436"/>
+                </a:solidFill>
+                <a:effectLst/>
+                <a:uFillTx/>
+              </a:rPr>
+              <a:t>una</a:t>
+            </a:r>
+            <a:r>
+              <a:rPr lang="en-US" sz="1400" b="0" u="none" strike="noStrike" dirty="0">
+                <a:solidFill>
+                  <a:srgbClr val="2D3436"/>
+                </a:solidFill>
+                <a:effectLst/>
+                <a:uFillTx/>
+              </a:rPr>
+              <a:t> </a:t>
+            </a:r>
+            <a:r>
+              <a:rPr lang="en-US" sz="1400" b="0" u="none" strike="noStrike" dirty="0" err="1">
+                <a:solidFill>
+                  <a:srgbClr val="2D3436"/>
+                </a:solidFill>
+                <a:effectLst/>
+                <a:uFillTx/>
+              </a:rPr>
+              <a:t>primera</a:t>
+            </a:r>
+            <a:r>
+              <a:rPr lang="en-US" sz="1400" b="0" u="none" strike="noStrike" dirty="0">
+                <a:solidFill>
+                  <a:srgbClr val="2D3436"/>
+                </a:solidFill>
+                <a:effectLst/>
+                <a:uFillTx/>
+              </a:rPr>
+              <a:t> </a:t>
+            </a:r>
+            <a:r>
+              <a:rPr lang="en-US" sz="1400" b="0" u="none" strike="noStrike" dirty="0" err="1">
+                <a:solidFill>
+                  <a:srgbClr val="2D3436"/>
+                </a:solidFill>
+                <a:effectLst/>
+                <a:uFillTx/>
+              </a:rPr>
+              <a:t>etiqueta</a:t>
+            </a:r>
+            <a:r>
+              <a:rPr lang="en-US" sz="1400" b="0" u="none" strike="noStrike" dirty="0">
+                <a:solidFill>
+                  <a:srgbClr val="2D3436"/>
+                </a:solidFill>
+                <a:effectLst/>
+                <a:uFillTx/>
+              </a:rPr>
+              <a:t>.</a:t>
+            </a:r>
+            <a:endParaRPr lang="en-US" sz="1400" b="0" u="none" strike="noStrike" dirty="0">
               <a:solidFill>
                 <a:srgbClr val="000000"/>
               </a:solidFill>
@@ -15402,25 +18363,157 @@
             </a:endParaRPr>
           </a:p>
           <a:p>
-            <a:pPr defTabSz="457200">
+            <a:pPr marL="285750" indent="-285750" defTabSz="457200">
               <a:lnSpc>
                 <a:spcPct val="100000"/>
               </a:lnSpc>
               <a:spcAft>
                 <a:spcPts val="600"/>
               </a:spcAft>
+              <a:buFont typeface="Arial" panose="020B0604020202020204" pitchFamily="34" charset="0"/>
+              <a:buChar char="•"/>
             </a:pPr>
             <a:r>
-              <a:rPr lang="en-US" sz="1400" b="0" u="none" strike="noStrike">
-                <a:solidFill>
-                  <a:srgbClr val="2D3436"/>
-                </a:solidFill>
-                <a:effectLst/>
-                <a:uFillTx/>
-              </a:rPr>
-              <a:t>Distinguir entre versionar información útil y publicar secretos o ruido.</a:t>
-            </a:r>
-            <a:endParaRPr lang="en-US" sz="1400" b="0" u="none" strike="noStrike">
+              <a:rPr lang="en-US" sz="1400" b="0" u="none" strike="noStrike" dirty="0" err="1">
+                <a:solidFill>
+                  <a:srgbClr val="2D3436"/>
+                </a:solidFill>
+                <a:effectLst/>
+                <a:uFillTx/>
+              </a:rPr>
+              <a:t>Distinguir</a:t>
+            </a:r>
+            <a:r>
+              <a:rPr lang="en-US" sz="1400" b="0" u="none" strike="noStrike" dirty="0">
+                <a:solidFill>
+                  <a:srgbClr val="2D3436"/>
+                </a:solidFill>
+                <a:effectLst/>
+                <a:uFillTx/>
+              </a:rPr>
+              <a:t> entre </a:t>
+            </a:r>
+            <a:r>
+              <a:rPr lang="en-US" sz="1400" b="0" u="none" strike="noStrike" dirty="0" err="1">
+                <a:solidFill>
+                  <a:srgbClr val="2D3436"/>
+                </a:solidFill>
+                <a:effectLst/>
+                <a:uFillTx/>
+              </a:rPr>
+              <a:t>versionar</a:t>
+            </a:r>
+            <a:r>
+              <a:rPr lang="en-US" sz="1400" b="0" u="none" strike="noStrike" dirty="0">
+                <a:solidFill>
+                  <a:srgbClr val="2D3436"/>
+                </a:solidFill>
+                <a:effectLst/>
+                <a:uFillTx/>
+              </a:rPr>
+              <a:t> </a:t>
+            </a:r>
+            <a:r>
+              <a:rPr lang="en-US" sz="1400" b="0" u="none" strike="noStrike" dirty="0" err="1">
+                <a:solidFill>
+                  <a:srgbClr val="2D3436"/>
+                </a:solidFill>
+                <a:effectLst/>
+                <a:uFillTx/>
+              </a:rPr>
+              <a:t>información</a:t>
+            </a:r>
+            <a:r>
+              <a:rPr lang="en-US" sz="1400" b="0" u="none" strike="noStrike" dirty="0">
+                <a:solidFill>
+                  <a:srgbClr val="2D3436"/>
+                </a:solidFill>
+                <a:effectLst/>
+                <a:uFillTx/>
+              </a:rPr>
+              <a:t> </a:t>
+            </a:r>
+            <a:r>
+              <a:rPr lang="en-US" sz="1400" b="0" u="none" strike="noStrike" dirty="0" err="1">
+                <a:solidFill>
+                  <a:srgbClr val="2D3436"/>
+                </a:solidFill>
+                <a:effectLst/>
+                <a:uFillTx/>
+              </a:rPr>
+              <a:t>útil</a:t>
+            </a:r>
+            <a:r>
+              <a:rPr lang="en-US" sz="1400" b="0" u="none" strike="noStrike" dirty="0">
+                <a:solidFill>
+                  <a:srgbClr val="2D3436"/>
+                </a:solidFill>
+                <a:effectLst/>
+                <a:uFillTx/>
+              </a:rPr>
+              <a:t> y </a:t>
+            </a:r>
+            <a:r>
+              <a:rPr lang="en-US" sz="1400" b="0" u="none" strike="noStrike" dirty="0" err="1">
+                <a:solidFill>
+                  <a:srgbClr val="2D3436"/>
+                </a:solidFill>
+                <a:effectLst/>
+                <a:uFillTx/>
+              </a:rPr>
+              <a:t>publicar</a:t>
+            </a:r>
+            <a:r>
+              <a:rPr lang="en-US" sz="1400" b="0" u="none" strike="noStrike" dirty="0">
+                <a:solidFill>
+                  <a:srgbClr val="2D3436"/>
+                </a:solidFill>
+                <a:effectLst/>
+                <a:uFillTx/>
+              </a:rPr>
+              <a:t> </a:t>
+            </a:r>
+            <a:r>
+              <a:rPr lang="en-US" sz="1400" b="0" u="none" strike="noStrike" dirty="0" err="1">
+                <a:solidFill>
+                  <a:srgbClr val="2D3436"/>
+                </a:solidFill>
+                <a:effectLst/>
+                <a:uFillTx/>
+              </a:rPr>
+              <a:t>secretos</a:t>
+            </a:r>
+            <a:r>
+              <a:rPr lang="en-US" sz="1400" b="0" u="none" strike="noStrike" dirty="0">
+                <a:solidFill>
+                  <a:srgbClr val="2D3436"/>
+                </a:solidFill>
+                <a:effectLst/>
+                <a:uFillTx/>
+              </a:rPr>
+              <a:t> o </a:t>
+            </a:r>
+            <a:r>
+              <a:rPr lang="en-US" sz="1400" b="0" u="none" strike="noStrike" dirty="0" err="1">
+                <a:solidFill>
+                  <a:srgbClr val="2D3436"/>
+                </a:solidFill>
+                <a:effectLst/>
+                <a:uFillTx/>
+              </a:rPr>
+              <a:t>ruido</a:t>
+            </a:r>
+            <a:r>
+              <a:rPr lang="en-US" sz="1400" b="0" u="none" strike="noStrike" dirty="0">
+                <a:solidFill>
+                  <a:srgbClr val="2D3436"/>
+                </a:solidFill>
+                <a:effectLst/>
+                <a:uFillTx/>
+              </a:rPr>
+              <a:t>.</a:t>
+            </a:r>
+            <a:endParaRPr lang="en-US" sz="1400" b="0" u="none" strike="noStrike" dirty="0">
               <a:solidFill>
                 <a:srgbClr val="000000"/>
               </a:solidFill>
@@ -15438,7 +18531,7 @@
 </p:sld>
 </file>
 
-<file path=ppt/slides/slide15.xml><?xml version="1.0" encoding="utf-8"?>
+<file path=ppt/slides/slide16.xml><?xml version="1.0" encoding="utf-8"?>
 <p:sld xmlns:a="http://schemas.openxmlformats.org/drawingml/2006/main" xmlns:r="http://schemas.openxmlformats.org/officeDocument/2006/relationships" xmlns:p="http://schemas.openxmlformats.org/presentationml/2006/main">
   <p:cSld>
     <p:bg>
@@ -23727,7 +26820,7 @@
         </p:nvSpPr>
         <p:spPr>
           <a:xfrm>
-            <a:off x="1503459" y="3682890"/>
+            <a:off x="1269542" y="3676050"/>
             <a:ext cx="6400440" cy="1096920"/>
           </a:xfrm>
           <a:prstGeom prst="roundRect">

</xml_diff>